<commit_message>
deck: add forward-R&D slide (orthogonal GBM + co-attention) + fix stale repo link
New slide 12 "Where this points": the diversity analysis -> orthogonal feature-GBM
(rank-corr 0.41, leave-patients-out 0.82 AUC), ResNet-50 underdelivered (0.79, corr
0.90), and intermediate co-attention (CAFNet) on EfficientNet as the SOTA-grounded
next step. Honest framing (implemented + locally validated, LB pending). Take-home
renumbered to slide 13. Fixed the stale GitHub link (A3-ADL -> the real repo name,
multimodal-microscopy-distillation). Re-rendered A3_cancer_challenge_claude.pptx (13 slides).

Co-Authored-By: Claude Opus 4.8 <noreply@anthropic.com>
</commit_message>
<xml_diff>
--- a/presentation/A3_cancer_challenge_claude.pptx
+++ b/presentation/A3_cancer_challenge_claude.pptx
@@ -17,9 +17,10 @@
     <p:sldId id="265" r:id="rId11"/>
     <p:sldId id="266" r:id="rId12"/>
     <p:sldId id="267" r:id="rId13"/>
+    <p:sldId id="268" r:id="rId14"/>
   </p:sldIdLst>
   <p:notesMasterIdLst>
-    <p:notesMasterId r:id="rId14"/>
+    <p:notesMasterId r:id="rId15"/>
   </p:notesMasterIdLst>
   <p:sldSz cx="9144000" cy="5143500"/>
   <p:notesSz cx="5143500" cy="9144000"/>
@@ -796,13 +797,10 @@
           <a:p>
             <a:r>
               <a:rPr lang="en-US" dirty="0"/>
-              <a:t>Five things to carry forward.
-One. Higher CV doesn't mean higher LB. v15 had my best cross-validation, 0.866, and my worst leaderboard, 0.572. If you only have CV, you don't know what you have. On patient-grouped OOD, CV alone is not a signal.
-Two. Don't stack unvalidated changes. v43 added four tweaks at once on top of v41 and regressed by 0.012 LB. The run cost 5 hours of GPU and produced no isolable signal. I now change at most one or two related variables per submission.
-Three. Seed variance is huge. v23 was v19 with only the random seed changed. 0.03 LB shift. Most A/B comparisons with deltas under 0.03 are noise, not signal.
-Four. On 12 patients, dataset size beats regularization. Four textbook regularizers gained 0.011 LB. Soft pseudo + noisy-student round 2 gained 0.042 LB. About 3.8× larger lift from the data lever than the model lever.
-Five. Negative results are the methodology. The v46 and v47 winning recipes are direct responses to six diagnosed failures: v22, v27, v37, v38, v42, v43, and v45_probe. Reading the failures faithfully is what produced the win.
-Thanks. Full code and version-by-version LB history at github.com/rafallex/A3-ADL. Questions?</a:t>
+              <a:t>Where the analysis points next — the honest forward story past v47.
+Core finding: every strong model I have is an EfficientNet-B0 variant, so they're all &gt;0.94 rank-correlated. That's exactly why symmetric averaging never beats the best single seed. I tried a ResNet-50 under the same soft-pseudo recipe — it came out weak (0.79 LB) and MORE correlated (0.90), not less. Diversity within the CNN family is bounded.
+So the real lever is a model from a different representation entirely: a gradient-boosted tree on 87 hand-crafted features — intensity, Otsu morphology, GLCM/LBP texture, and a cross-modal BF-FL correlation feature. Leave-patients-out it hits 0.82 AUC — on par with the CNN — but its rank-correlation with the best CNN is only 0.41, less than half of anything else. That is the ideal ensemble ingredient, and it shows FL carries more signal than BF (0.76 vs 0.72 alone).
+Finally the architecture the source paper reports as state of the art — intermediate co-attention fusion, CAFNet — applied to EfficientNet (not their ResNet, which is weak here), hardened for mixed precision. All implemented and locally validated; leaderboard numbers pending.</a:t>
             </a:r>
             <a:endParaRPr lang="en-US" dirty="0"/>
           </a:p>
@@ -826,6 +824,100 @@
             <a:fld id="{F7021451-1387-4CA6-816F-3879F97B5CBC}" type="slidenum">
               <a:rPr lang="en-US"/>
               <a:t>12</a:t>
+            </a:fld>
+            <a:endParaRPr lang="en-US"/>
+          </a:p>
+        </p:txBody>
+      </p:sp>
+    </p:spTree>
+    <p:extLst>
+      <p:ext uri="{BB962C8B-B14F-4D97-AF65-F5344CB8AC3E}">
+        <p14:creationId xmlns:p14="http://schemas.microsoft.com/office/powerpoint/2010/main" val="1024086991"/>
+      </p:ext>
+    </p:extLst>
+  </p:cSld>
+  <p:clrMapOvr>
+    <a:masterClrMapping/>
+  </p:clrMapOvr>
+</p:notes>
+</file>
+
+<file path=ppt/notesSlides/notesSlide13.xml><?xml version="1.0" encoding="utf-8"?>
+<p:notes xmlns:a="http://schemas.openxmlformats.org/drawingml/2006/main" xmlns:r="http://schemas.openxmlformats.org/officeDocument/2006/relationships" xmlns:p="http://schemas.openxmlformats.org/presentationml/2006/main">
+  <p:cSld>
+    <p:spTree>
+      <p:nvGrpSpPr>
+        <p:cNvPr id="1" name=""/>
+        <p:cNvGrpSpPr/>
+        <p:nvPr/>
+      </p:nvGrpSpPr>
+      <p:grpSpPr>
+        <a:xfrm>
+          <a:off x="0" y="0"/>
+          <a:ext cx="0" cy="0"/>
+          <a:chOff x="0" y="0"/>
+          <a:chExt cx="0" cy="0"/>
+        </a:xfrm>
+      </p:grpSpPr>
+      <p:sp>
+        <p:nvSpPr>
+          <p:cNvPr id="2" name="Slide Image Placeholder 1"/>
+          <p:cNvSpPr>
+            <a:spLocks noGrp="1" noRot="1" noChangeAspect="1"/>
+          </p:cNvSpPr>
+          <p:nvPr>
+            <p:ph type="sldImg"/>
+          </p:nvPr>
+        </p:nvSpPr>
+        <p:spPr/>
+      </p:sp>
+      <p:sp>
+        <p:nvSpPr>
+          <p:cNvPr id="3" name="Notes Placeholder 2"/>
+          <p:cNvSpPr>
+            <a:spLocks noGrp="1"/>
+          </p:cNvSpPr>
+          <p:nvPr>
+            <p:ph type="body" idx="1"/>
+          </p:nvPr>
+        </p:nvSpPr>
+        <p:spPr/>
+        <p:txBody>
+          <a:bodyPr/>
+          <a:lstStyle/>
+          <a:p>
+            <a:r>
+              <a:rPr lang="en-US" dirty="0"/>
+              <a:t>Five things to carry forward.
+One. Higher CV doesn't mean higher LB. v15 had my best cross-validation, 0.866, and my worst leaderboard, 0.572. If you only have CV, you don't know what you have. On patient-grouped OOD, CV alone is not a signal.
+Two. Don't stack unvalidated changes. v43 added four tweaks at once on top of v41 and regressed by 0.012 LB. The run cost 5 hours of GPU and produced no isolable signal. I now change at most one or two related variables per submission.
+Three. Seed variance is huge. v23 was v19 with only the random seed changed. 0.03 LB shift. Most A/B comparisons with deltas under 0.03 are noise, not signal.
+Four. On 12 patients, dataset size beats regularization. Four textbook regularizers gained 0.011 LB. Soft pseudo + noisy-student round 2 gained 0.042 LB. About 3.8× larger lift from the data lever than the model lever.
+Five. Negative results are the methodology. The v46 and v47 winning recipes are direct responses to six diagnosed failures: v22, v27, v37, v38, v42, v43, and v45_probe. Reading the failures faithfully is what produced the win.
+Thanks. Full code and version-by-version LB history at github.com/rafallex/multimodal-microscopy-distillation. Questions?</a:t>
+            </a:r>
+            <a:endParaRPr lang="en-US" dirty="0"/>
+          </a:p>
+        </p:txBody>
+      </p:sp>
+      <p:sp>
+        <p:nvSpPr>
+          <p:cNvPr id="4" name="Slide Number Placeholder 3"/>
+          <p:cNvSpPr>
+            <a:spLocks noGrp="1"/>
+          </p:cNvSpPr>
+          <p:nvPr>
+            <p:ph type="sldNum" sz="quarter" idx="10"/>
+          </p:nvPr>
+        </p:nvSpPr>
+        <p:spPr/>
+        <p:txBody>
+          <a:bodyPr/>
+          <a:lstStyle/>
+          <a:p>
+            <a:fld id="{F7021451-1387-4CA6-816F-3879F97B5CBC}" type="slidenum">
+              <a:rPr lang="en-US"/>
+              <a:t>13</a:t>
             </a:fld>
             <a:endParaRPr lang="en-US"/>
           </a:p>
@@ -2711,7 +2803,7 @@
                 <a:ea typeface="Calibri" pitchFamily="34" charset="-122"/>
                 <a:cs typeface="Calibri" pitchFamily="34" charset="-120"/>
               </a:rPr>
-              <a:t>10 / 12</a:t>
+              <a:t>10 / 13</a:t>
             </a:r>
             <a:endParaRPr lang="en-US" sz="1000" dirty="0"/>
           </a:p>
@@ -3028,7 +3120,7 @@
                 <a:ea typeface="Calibri" pitchFamily="34" charset="-122"/>
                 <a:cs typeface="Calibri" pitchFamily="34" charset="-120"/>
               </a:rPr>
-              <a:t>11 / 12</a:t>
+              <a:t>11 / 13</a:t>
             </a:r>
             <a:endParaRPr lang="en-US" sz="1000" dirty="0"/>
           </a:p>
@@ -4829,6 +4921,1004 @@
 <file path=ppt/slides/slide12.xml><?xml version="1.0" encoding="utf-8"?>
 <p:sld xmlns:a="http://schemas.openxmlformats.org/drawingml/2006/main" xmlns:r="http://schemas.openxmlformats.org/officeDocument/2006/relationships" xmlns:p="http://schemas.openxmlformats.org/presentationml/2006/main">
   <p:cSld name="Slide 12">
+    <p:bg>
+      <p:bgPr>
+        <a:solidFill>
+          <a:srgbClr val="FAF7F2"/>
+        </a:solidFill>
+      </p:bgPr>
+    </p:bg>
+    <p:spTree>
+      <p:nvGrpSpPr>
+        <p:cNvPr id="1" name=""/>
+        <p:cNvGrpSpPr/>
+        <p:nvPr/>
+      </p:nvGrpSpPr>
+      <p:grpSpPr>
+        <a:xfrm>
+          <a:off x="0" y="0"/>
+          <a:ext cx="0" cy="0"/>
+          <a:chOff x="0" y="0"/>
+          <a:chExt cx="0" cy="0"/>
+        </a:xfrm>
+      </p:grpSpPr>
+      <p:sp>
+        <p:nvSpPr>
+          <p:cNvPr id="2" name="Text 0"/>
+          <p:cNvSpPr/>
+          <p:nvPr/>
+        </p:nvSpPr>
+        <p:spPr>
+          <a:xfrm>
+            <a:off x="274320" y="201168"/>
+            <a:ext cx="6858000" cy="274320"/>
+          </a:xfrm>
+          <a:prstGeom prst="rect">
+            <a:avLst/>
+          </a:prstGeom>
+          <a:noFill/>
+          <a:ln/>
+        </p:spPr>
+        <p:txBody>
+          <a:bodyPr wrap="square" lIns="0" tIns="0" rIns="0" bIns="0" rtlCol="0" anchor="ctr"/>
+          <a:lstStyle/>
+          <a:p>
+            <a:pPr indent="0" marL="0">
+              <a:buNone/>
+            </a:pPr>
+            <a:r>
+              <a:rPr lang="en-US" sz="1050" b="1" spc="500" kern="0" dirty="0">
+                <a:solidFill>
+                  <a:srgbClr val="0D9488"/>
+                </a:solidFill>
+                <a:latin typeface="Calibri" pitchFamily="34" charset="0"/>
+                <a:ea typeface="Calibri" pitchFamily="34" charset="-122"/>
+                <a:cs typeface="Calibri" pitchFamily="34" charset="-120"/>
+              </a:rPr>
+              <a:t>§10  ·  WHERE THIS POINTS</a:t>
+            </a:r>
+            <a:endParaRPr lang="en-US" sz="1050" dirty="0"/>
+          </a:p>
+        </p:txBody>
+      </p:sp>
+      <p:sp>
+        <p:nvSpPr>
+          <p:cNvPr id="3" name="Text 1"/>
+          <p:cNvSpPr/>
+          <p:nvPr/>
+        </p:nvSpPr>
+        <p:spPr>
+          <a:xfrm>
+            <a:off x="7589520" y="201168"/>
+            <a:ext cx="1280160" cy="274320"/>
+          </a:xfrm>
+          <a:prstGeom prst="rect">
+            <a:avLst/>
+          </a:prstGeom>
+          <a:noFill/>
+          <a:ln/>
+        </p:spPr>
+        <p:txBody>
+          <a:bodyPr wrap="square" lIns="0" tIns="0" rIns="0" bIns="0" rtlCol="0" anchor="ctr"/>
+          <a:lstStyle/>
+          <a:p>
+            <a:pPr algn="r" indent="0" marL="0">
+              <a:buNone/>
+            </a:pPr>
+            <a:r>
+              <a:rPr lang="en-US" sz="1000" dirty="0">
+                <a:solidFill>
+                  <a:srgbClr val="64748B"/>
+                </a:solidFill>
+                <a:latin typeface="Calibri" pitchFamily="34" charset="0"/>
+                <a:ea typeface="Calibri" pitchFamily="34" charset="-122"/>
+                <a:cs typeface="Calibri" pitchFamily="34" charset="-120"/>
+              </a:rPr>
+              <a:t>12 / 13</a:t>
+            </a:r>
+            <a:endParaRPr lang="en-US" sz="1000" dirty="0"/>
+          </a:p>
+        </p:txBody>
+      </p:sp>
+      <p:sp>
+        <p:nvSpPr>
+          <p:cNvPr id="4" name="Shape 2"/>
+          <p:cNvSpPr/>
+          <p:nvPr/>
+        </p:nvSpPr>
+        <p:spPr>
+          <a:xfrm>
+            <a:off x="274320" y="475488"/>
+            <a:ext cx="8595360" cy="18288"/>
+          </a:xfrm>
+          <a:prstGeom prst="rect">
+            <a:avLst/>
+          </a:prstGeom>
+          <a:solidFill>
+            <a:srgbClr val="0D9488">
+              <a:alpha val="40000"/>
+            </a:srgbClr>
+          </a:solidFill>
+          <a:ln w="12700">
+            <a:solidFill>
+              <a:srgbClr val="0D9488"/>
+            </a:solidFill>
+            <a:prstDash val="solid"/>
+          </a:ln>
+        </p:spPr>
+      </p:sp>
+      <p:sp>
+        <p:nvSpPr>
+          <p:cNvPr id="5" name="Text 3"/>
+          <p:cNvSpPr/>
+          <p:nvPr/>
+        </p:nvSpPr>
+        <p:spPr>
+          <a:xfrm>
+            <a:off x="274320" y="594360"/>
+            <a:ext cx="8595360" cy="777240"/>
+          </a:xfrm>
+          <a:prstGeom prst="rect">
+            <a:avLst/>
+          </a:prstGeom>
+          <a:noFill/>
+          <a:ln/>
+        </p:spPr>
+        <p:txBody>
+          <a:bodyPr wrap="square" lIns="0" tIns="0" rIns="0" bIns="0" rtlCol="0" anchor="ctr"/>
+          <a:lstStyle/>
+          <a:p>
+            <a:pPr indent="0" marL="0">
+              <a:buNone/>
+            </a:pPr>
+            <a:r>
+              <a:rPr lang="en-US" sz="2600" b="1" dirty="0">
+                <a:solidFill>
+                  <a:srgbClr val="1A3A52"/>
+                </a:solidFill>
+                <a:latin typeface="Georgia" pitchFamily="34" charset="0"/>
+                <a:ea typeface="Georgia" pitchFamily="34" charset="-122"/>
+                <a:cs typeface="Georgia" pitchFamily="34" charset="-120"/>
+              </a:rPr>
+              <a:t>The next gain is decorrelation, not more EfficientNet</a:t>
+            </a:r>
+            <a:endParaRPr lang="en-US" sz="2600" dirty="0"/>
+          </a:p>
+        </p:txBody>
+      </p:sp>
+      <p:sp>
+        <p:nvSpPr>
+          <p:cNvPr id="6" name="Shape 4"/>
+          <p:cNvSpPr/>
+          <p:nvPr/>
+        </p:nvSpPr>
+        <p:spPr>
+          <a:xfrm>
+            <a:off x="274320" y="1554480"/>
+            <a:ext cx="2743200" cy="1188720"/>
+          </a:xfrm>
+          <a:prstGeom prst="rect">
+            <a:avLst/>
+          </a:prstGeom>
+          <a:solidFill>
+            <a:srgbClr val="FFFFFF"/>
+          </a:solidFill>
+          <a:ln w="6350">
+            <a:solidFill>
+              <a:srgbClr val="E5E7EB"/>
+            </a:solidFill>
+            <a:prstDash val="solid"/>
+          </a:ln>
+          <a:effectLst>
+            <a:outerShdw sx="100000" sy="100000" kx="0" ky="0" algn="bl" rotWithShape="0" blurRad="63500" dist="19050" dir="5400000">
+              <a:srgbClr val="000000">
+                <a:alpha val="6000"/>
+              </a:srgbClr>
+            </a:outerShdw>
+          </a:effectLst>
+        </p:spPr>
+      </p:sp>
+      <p:sp>
+        <p:nvSpPr>
+          <p:cNvPr id="7" name="Shape 5"/>
+          <p:cNvSpPr/>
+          <p:nvPr/>
+        </p:nvSpPr>
+        <p:spPr>
+          <a:xfrm>
+            <a:off x="274320" y="1554480"/>
+            <a:ext cx="64008" cy="1188720"/>
+          </a:xfrm>
+          <a:prstGeom prst="rect">
+            <a:avLst/>
+          </a:prstGeom>
+          <a:solidFill>
+            <a:srgbClr val="0D9488"/>
+          </a:solidFill>
+          <a:ln w="12700">
+            <a:solidFill>
+              <a:srgbClr val="0D9488"/>
+            </a:solidFill>
+            <a:prstDash val="solid"/>
+          </a:ln>
+        </p:spPr>
+      </p:sp>
+      <p:sp>
+        <p:nvSpPr>
+          <p:cNvPr id="8" name="Text 6"/>
+          <p:cNvSpPr/>
+          <p:nvPr/>
+        </p:nvSpPr>
+        <p:spPr>
+          <a:xfrm>
+            <a:off x="457200" y="1645920"/>
+            <a:ext cx="2468880" cy="653796"/>
+          </a:xfrm>
+          <a:prstGeom prst="rect">
+            <a:avLst/>
+          </a:prstGeom>
+          <a:noFill/>
+          <a:ln/>
+        </p:spPr>
+        <p:txBody>
+          <a:bodyPr wrap="square" lIns="0" tIns="0" rIns="0" bIns="0" rtlCol="0" anchor="t"/>
+          <a:lstStyle/>
+          <a:p>
+            <a:pPr algn="l" indent="0" marL="0">
+              <a:buNone/>
+            </a:pPr>
+            <a:r>
+              <a:rPr lang="en-US" sz="3800" b="1" dirty="0">
+                <a:solidFill>
+                  <a:srgbClr val="0D9488"/>
+                </a:solidFill>
+                <a:latin typeface="Georgia" pitchFamily="34" charset="0"/>
+                <a:ea typeface="Georgia" pitchFamily="34" charset="-122"/>
+                <a:cs typeface="Georgia" pitchFamily="34" charset="-120"/>
+              </a:rPr>
+              <a:t>0.41</a:t>
+            </a:r>
+            <a:endParaRPr lang="en-US" sz="3800" dirty="0"/>
+          </a:p>
+        </p:txBody>
+      </p:sp>
+      <p:sp>
+        <p:nvSpPr>
+          <p:cNvPr id="9" name="Text 7"/>
+          <p:cNvSpPr/>
+          <p:nvPr/>
+        </p:nvSpPr>
+        <p:spPr>
+          <a:xfrm>
+            <a:off x="457200" y="2208276"/>
+            <a:ext cx="2468880" cy="534924"/>
+          </a:xfrm>
+          <a:prstGeom prst="rect">
+            <a:avLst/>
+          </a:prstGeom>
+          <a:noFill/>
+          <a:ln/>
+        </p:spPr>
+        <p:txBody>
+          <a:bodyPr wrap="square" lIns="0" tIns="0" rIns="0" bIns="0" rtlCol="0" anchor="t"/>
+          <a:lstStyle/>
+          <a:p>
+            <a:pPr algn="l" indent="0" marL="0">
+              <a:buNone/>
+            </a:pPr>
+            <a:r>
+              <a:rPr lang="en-US" sz="900" dirty="0">
+                <a:solidFill>
+                  <a:srgbClr val="64748B"/>
+                </a:solidFill>
+                <a:latin typeface="Calibri" pitchFamily="34" charset="0"/>
+                <a:ea typeface="Calibri" pitchFamily="34" charset="-122"/>
+                <a:cs typeface="Calibri" pitchFamily="34" charset="-120"/>
+              </a:rPr>
+              <a:t>feature-GBM rank-corr vs the best CNN (the EffNet fleet is &gt; 0.94)</a:t>
+            </a:r>
+            <a:endParaRPr lang="en-US" sz="900" dirty="0"/>
+          </a:p>
+        </p:txBody>
+      </p:sp>
+      <p:sp>
+        <p:nvSpPr>
+          <p:cNvPr id="10" name="Shape 8"/>
+          <p:cNvSpPr/>
+          <p:nvPr/>
+        </p:nvSpPr>
+        <p:spPr>
+          <a:xfrm>
+            <a:off x="3200400" y="1554480"/>
+            <a:ext cx="2743200" cy="1188720"/>
+          </a:xfrm>
+          <a:prstGeom prst="rect">
+            <a:avLst/>
+          </a:prstGeom>
+          <a:solidFill>
+            <a:srgbClr val="FFFFFF"/>
+          </a:solidFill>
+          <a:ln w="6350">
+            <a:solidFill>
+              <a:srgbClr val="E5E7EB"/>
+            </a:solidFill>
+            <a:prstDash val="solid"/>
+          </a:ln>
+          <a:effectLst>
+            <a:outerShdw sx="100000" sy="100000" kx="0" ky="0" algn="bl" rotWithShape="0" blurRad="63500" dist="19050" dir="5400000">
+              <a:srgbClr val="000000">
+                <a:alpha val="6000"/>
+              </a:srgbClr>
+            </a:outerShdw>
+          </a:effectLst>
+        </p:spPr>
+      </p:sp>
+      <p:sp>
+        <p:nvSpPr>
+          <p:cNvPr id="11" name="Shape 9"/>
+          <p:cNvSpPr/>
+          <p:nvPr/>
+        </p:nvSpPr>
+        <p:spPr>
+          <a:xfrm>
+            <a:off x="3200400" y="1554480"/>
+            <a:ext cx="64008" cy="1188720"/>
+          </a:xfrm>
+          <a:prstGeom prst="rect">
+            <a:avLst/>
+          </a:prstGeom>
+          <a:solidFill>
+            <a:srgbClr val="1A3A52"/>
+          </a:solidFill>
+          <a:ln w="12700">
+            <a:solidFill>
+              <a:srgbClr val="1A3A52"/>
+            </a:solidFill>
+            <a:prstDash val="solid"/>
+          </a:ln>
+        </p:spPr>
+      </p:sp>
+      <p:sp>
+        <p:nvSpPr>
+          <p:cNvPr id="12" name="Text 10"/>
+          <p:cNvSpPr/>
+          <p:nvPr/>
+        </p:nvSpPr>
+        <p:spPr>
+          <a:xfrm>
+            <a:off x="3383280" y="1645920"/>
+            <a:ext cx="2468880" cy="653796"/>
+          </a:xfrm>
+          <a:prstGeom prst="rect">
+            <a:avLst/>
+          </a:prstGeom>
+          <a:noFill/>
+          <a:ln/>
+        </p:spPr>
+        <p:txBody>
+          <a:bodyPr wrap="square" lIns="0" tIns="0" rIns="0" bIns="0" rtlCol="0" anchor="t"/>
+          <a:lstStyle/>
+          <a:p>
+            <a:pPr algn="l" indent="0" marL="0">
+              <a:buNone/>
+            </a:pPr>
+            <a:r>
+              <a:rPr lang="en-US" sz="3800" b="1" dirty="0">
+                <a:solidFill>
+                  <a:srgbClr val="1A3A52"/>
+                </a:solidFill>
+                <a:latin typeface="Georgia" pitchFamily="34" charset="0"/>
+                <a:ea typeface="Georgia" pitchFamily="34" charset="-122"/>
+                <a:cs typeface="Georgia" pitchFamily="34" charset="-120"/>
+              </a:rPr>
+              <a:t>0.82</a:t>
+            </a:r>
+            <a:endParaRPr lang="en-US" sz="3800" dirty="0"/>
+          </a:p>
+        </p:txBody>
+      </p:sp>
+      <p:sp>
+        <p:nvSpPr>
+          <p:cNvPr id="13" name="Text 11"/>
+          <p:cNvSpPr/>
+          <p:nvPr/>
+        </p:nvSpPr>
+        <p:spPr>
+          <a:xfrm>
+            <a:off x="3383280" y="2208276"/>
+            <a:ext cx="2468880" cy="534924"/>
+          </a:xfrm>
+          <a:prstGeom prst="rect">
+            <a:avLst/>
+          </a:prstGeom>
+          <a:noFill/>
+          <a:ln/>
+        </p:spPr>
+        <p:txBody>
+          <a:bodyPr wrap="square" lIns="0" tIns="0" rIns="0" bIns="0" rtlCol="0" anchor="t"/>
+          <a:lstStyle/>
+          <a:p>
+            <a:pPr algn="l" indent="0" marL="0">
+              <a:buNone/>
+            </a:pPr>
+            <a:r>
+              <a:rPr lang="en-US" sz="900" dirty="0">
+                <a:solidFill>
+                  <a:srgbClr val="64748B"/>
+                </a:solidFill>
+                <a:latin typeface="Calibri" pitchFamily="34" charset="0"/>
+                <a:ea typeface="Calibri" pitchFamily="34" charset="-122"/>
+                <a:cs typeface="Calibri" pitchFamily="34" charset="-120"/>
+              </a:rPr>
+              <a:t>its leave-patients-out AUC — on par with the CNN</a:t>
+            </a:r>
+            <a:endParaRPr lang="en-US" sz="900" dirty="0"/>
+          </a:p>
+        </p:txBody>
+      </p:sp>
+      <p:sp>
+        <p:nvSpPr>
+          <p:cNvPr id="14" name="Shape 12"/>
+          <p:cNvSpPr/>
+          <p:nvPr/>
+        </p:nvSpPr>
+        <p:spPr>
+          <a:xfrm>
+            <a:off x="6126480" y="1554480"/>
+            <a:ext cx="2743200" cy="1188720"/>
+          </a:xfrm>
+          <a:prstGeom prst="rect">
+            <a:avLst/>
+          </a:prstGeom>
+          <a:solidFill>
+            <a:srgbClr val="FFFFFF"/>
+          </a:solidFill>
+          <a:ln w="6350">
+            <a:solidFill>
+              <a:srgbClr val="E5E7EB"/>
+            </a:solidFill>
+            <a:prstDash val="solid"/>
+          </a:ln>
+          <a:effectLst>
+            <a:outerShdw sx="100000" sy="100000" kx="0" ky="0" algn="bl" rotWithShape="0" blurRad="63500" dist="19050" dir="5400000">
+              <a:srgbClr val="000000">
+                <a:alpha val="6000"/>
+              </a:srgbClr>
+            </a:outerShdw>
+          </a:effectLst>
+        </p:spPr>
+      </p:sp>
+      <p:sp>
+        <p:nvSpPr>
+          <p:cNvPr id="15" name="Shape 13"/>
+          <p:cNvSpPr/>
+          <p:nvPr/>
+        </p:nvSpPr>
+        <p:spPr>
+          <a:xfrm>
+            <a:off x="6126480" y="1554480"/>
+            <a:ext cx="64008" cy="1188720"/>
+          </a:xfrm>
+          <a:prstGeom prst="rect">
+            <a:avLst/>
+          </a:prstGeom>
+          <a:solidFill>
+            <a:srgbClr val="B91C1C"/>
+          </a:solidFill>
+          <a:ln w="12700">
+            <a:solidFill>
+              <a:srgbClr val="B91C1C"/>
+            </a:solidFill>
+            <a:prstDash val="solid"/>
+          </a:ln>
+        </p:spPr>
+      </p:sp>
+      <p:sp>
+        <p:nvSpPr>
+          <p:cNvPr id="16" name="Text 14"/>
+          <p:cNvSpPr/>
+          <p:nvPr/>
+        </p:nvSpPr>
+        <p:spPr>
+          <a:xfrm>
+            <a:off x="6309360" y="1645920"/>
+            <a:ext cx="2468880" cy="653796"/>
+          </a:xfrm>
+          <a:prstGeom prst="rect">
+            <a:avLst/>
+          </a:prstGeom>
+          <a:noFill/>
+          <a:ln/>
+        </p:spPr>
+        <p:txBody>
+          <a:bodyPr wrap="square" lIns="0" tIns="0" rIns="0" bIns="0" rtlCol="0" anchor="t"/>
+          <a:lstStyle/>
+          <a:p>
+            <a:pPr algn="l" indent="0" marL="0">
+              <a:buNone/>
+            </a:pPr>
+            <a:r>
+              <a:rPr lang="en-US" sz="3800" b="1" dirty="0">
+                <a:solidFill>
+                  <a:srgbClr val="B91C1C"/>
+                </a:solidFill>
+                <a:latin typeface="Georgia" pitchFamily="34" charset="0"/>
+                <a:ea typeface="Georgia" pitchFamily="34" charset="-122"/>
+                <a:cs typeface="Georgia" pitchFamily="34" charset="-120"/>
+              </a:rPr>
+              <a:t>0.79</a:t>
+            </a:r>
+            <a:endParaRPr lang="en-US" sz="3800" dirty="0"/>
+          </a:p>
+        </p:txBody>
+      </p:sp>
+      <p:sp>
+        <p:nvSpPr>
+          <p:cNvPr id="17" name="Text 15"/>
+          <p:cNvSpPr/>
+          <p:nvPr/>
+        </p:nvSpPr>
+        <p:spPr>
+          <a:xfrm>
+            <a:off x="6309360" y="2208276"/>
+            <a:ext cx="2468880" cy="534924"/>
+          </a:xfrm>
+          <a:prstGeom prst="rect">
+            <a:avLst/>
+          </a:prstGeom>
+          <a:noFill/>
+          <a:ln/>
+        </p:spPr>
+        <p:txBody>
+          <a:bodyPr wrap="square" lIns="0" tIns="0" rIns="0" bIns="0" rtlCol="0" anchor="t"/>
+          <a:lstStyle/>
+          <a:p>
+            <a:pPr algn="l" indent="0" marL="0">
+              <a:buNone/>
+            </a:pPr>
+            <a:r>
+              <a:rPr lang="en-US" sz="900" dirty="0">
+                <a:solidFill>
+                  <a:srgbClr val="64748B"/>
+                </a:solidFill>
+                <a:latin typeface="Calibri" pitchFamily="34" charset="0"/>
+                <a:ea typeface="Calibri" pitchFamily="34" charset="-122"/>
+                <a:cs typeface="Calibri" pitchFamily="34" charset="-120"/>
+              </a:rPr>
+              <a:t>ResNet-50 LB — the within-CNN diversity bet underdelivered</a:t>
+            </a:r>
+            <a:endParaRPr lang="en-US" sz="900" dirty="0"/>
+          </a:p>
+        </p:txBody>
+      </p:sp>
+      <p:sp>
+        <p:nvSpPr>
+          <p:cNvPr id="18" name="Shape 16"/>
+          <p:cNvSpPr/>
+          <p:nvPr/>
+        </p:nvSpPr>
+        <p:spPr>
+          <a:xfrm>
+            <a:off x="274320" y="3017520"/>
+            <a:ext cx="36576" cy="1417320"/>
+          </a:xfrm>
+          <a:prstGeom prst="rect">
+            <a:avLst/>
+          </a:prstGeom>
+          <a:solidFill>
+            <a:srgbClr val="0D9488">
+              <a:alpha val="70000"/>
+            </a:srgbClr>
+          </a:solidFill>
+          <a:ln w="12700">
+            <a:solidFill>
+              <a:srgbClr val="0D9488"/>
+            </a:solidFill>
+            <a:prstDash val="solid"/>
+          </a:ln>
+        </p:spPr>
+      </p:sp>
+      <p:sp>
+        <p:nvSpPr>
+          <p:cNvPr id="19" name="Text 17"/>
+          <p:cNvSpPr/>
+          <p:nvPr/>
+        </p:nvSpPr>
+        <p:spPr>
+          <a:xfrm>
+            <a:off x="438912" y="3035808"/>
+            <a:ext cx="8394192" cy="1417320"/>
+          </a:xfrm>
+          <a:prstGeom prst="rect">
+            <a:avLst/>
+          </a:prstGeom>
+          <a:noFill/>
+          <a:ln/>
+        </p:spPr>
+        <p:txBody>
+          <a:bodyPr wrap="square" lIns="0" tIns="0" rIns="0" bIns="0" rtlCol="0" anchor="t"/>
+          <a:lstStyle/>
+          <a:p>
+            <a:pPr indent="0" marL="0">
+              <a:spcAft>
+                <a:spcPts val="600"/>
+              </a:spcAft>
+              <a:buNone/>
+            </a:pPr>
+            <a:r>
+              <a:rPr lang="en-US" sz="1050" b="1" dirty="0">
+                <a:solidFill>
+                  <a:srgbClr val="0D9488"/>
+                </a:solidFill>
+                <a:latin typeface="Calibri" pitchFamily="34" charset="0"/>
+                <a:ea typeface="Calibri" pitchFamily="34" charset="-122"/>
+                <a:cs typeface="Calibri" pitchFamily="34" charset="-120"/>
+              </a:rPr>
+              <a:t>— </a:t>
+            </a:r>
+            <a:pPr indent="0" marL="0">
+              <a:spcAft>
+                <a:spcPts val="600"/>
+              </a:spcAft>
+              <a:buNone/>
+            </a:pPr>
+            <a:r>
+              <a:rPr lang="en-US" sz="1050" b="1" dirty="0">
+                <a:solidFill>
+                  <a:srgbClr val="334155"/>
+                </a:solidFill>
+                <a:latin typeface="Calibri" pitchFamily="34" charset="0"/>
+                <a:ea typeface="Calibri" pitchFamily="34" charset="-122"/>
+                <a:cs typeface="Calibri" pitchFamily="34" charset="-120"/>
+              </a:rPr>
+              <a:t>The ceiling is correlation.</a:t>
+            </a:r>
+            <a:pPr indent="0" marL="0">
+              <a:spcAft>
+                <a:spcPts val="600"/>
+              </a:spcAft>
+              <a:buNone/>
+            </a:pPr>
+            <a:r>
+              <a:rPr lang="en-US" sz="950" i="1" dirty="0">
+                <a:solidFill>
+                  <a:srgbClr val="64748B"/>
+                </a:solidFill>
+                <a:latin typeface="Calibri" pitchFamily="34" charset="0"/>
+                <a:ea typeface="Calibri" pitchFamily="34" charset="-122"/>
+                <a:cs typeface="Calibri" pitchFamily="34" charset="-120"/>
+              </a:rPr>
+              <a:t>  Every strong model is EfficientNet-B0 (rank-corr &gt; 0.94); even a distilled ResNet-50 came out 0.90-correlated and weak (0.79). Symmetric averaging can't beat the best seed.</a:t>
+            </a:r>
+            <a:endParaRPr lang="en-US" sz="1050" dirty="0"/>
+          </a:p>
+          <a:p>
+            <a:pPr indent="0" marL="0">
+              <a:spcAft>
+                <a:spcPts val="600"/>
+              </a:spcAft>
+              <a:buNone/>
+            </a:pPr>
+            <a:r>
+              <a:rPr lang="en-US" sz="1050" b="1" dirty="0">
+                <a:solidFill>
+                  <a:srgbClr val="0D9488"/>
+                </a:solidFill>
+                <a:latin typeface="Calibri" pitchFamily="34" charset="0"/>
+                <a:ea typeface="Calibri" pitchFamily="34" charset="-122"/>
+                <a:cs typeface="Calibri" pitchFamily="34" charset="-120"/>
+              </a:rPr>
+              <a:t>— </a:t>
+            </a:r>
+            <a:pPr indent="0" marL="0">
+              <a:spcAft>
+                <a:spcPts val="600"/>
+              </a:spcAft>
+              <a:buNone/>
+            </a:pPr>
+            <a:r>
+              <a:rPr lang="en-US" sz="1050" b="1" dirty="0">
+                <a:solidFill>
+                  <a:srgbClr val="334155"/>
+                </a:solidFill>
+                <a:latin typeface="Calibri" pitchFamily="34" charset="0"/>
+                <a:ea typeface="Calibri" pitchFamily="34" charset="-122"/>
+                <a:cs typeface="Calibri" pitchFamily="34" charset="-120"/>
+              </a:rPr>
+              <a:t>The orthogonal member.</a:t>
+            </a:r>
+            <a:pPr indent="0" marL="0">
+              <a:spcAft>
+                <a:spcPts val="600"/>
+              </a:spcAft>
+              <a:buNone/>
+            </a:pPr>
+            <a:r>
+              <a:rPr lang="en-US" sz="950" i="1" dirty="0">
+                <a:solidFill>
+                  <a:srgbClr val="64748B"/>
+                </a:solidFill>
+                <a:latin typeface="Calibri" pitchFamily="34" charset="0"/>
+                <a:ea typeface="Calibri" pitchFamily="34" charset="-122"/>
+                <a:cs typeface="Calibri" pitchFamily="34" charset="-120"/>
+              </a:rPr>
+              <a:t>  A LightGBM on 87 hand-crafted morphology / texture / cross-modal features: rank-corr 0.41 — the first genuinely decorrelated model. FL carries more single-modality signal than BF.</a:t>
+            </a:r>
+            <a:endParaRPr lang="en-US" sz="1050" dirty="0"/>
+          </a:p>
+          <a:p>
+            <a:pPr indent="0" marL="0">
+              <a:spcAft>
+                <a:spcPts val="600"/>
+              </a:spcAft>
+              <a:buNone/>
+            </a:pPr>
+            <a:r>
+              <a:rPr lang="en-US" sz="1050" b="1" dirty="0">
+                <a:solidFill>
+                  <a:srgbClr val="0D9488"/>
+                </a:solidFill>
+                <a:latin typeface="Calibri" pitchFamily="34" charset="0"/>
+                <a:ea typeface="Calibri" pitchFamily="34" charset="-122"/>
+                <a:cs typeface="Calibri" pitchFamily="34" charset="-120"/>
+              </a:rPr>
+              <a:t>— </a:t>
+            </a:r>
+            <a:pPr indent="0" marL="0">
+              <a:spcAft>
+                <a:spcPts val="600"/>
+              </a:spcAft>
+              <a:buNone/>
+            </a:pPr>
+            <a:r>
+              <a:rPr lang="en-US" sz="1050" b="1" dirty="0">
+                <a:solidFill>
+                  <a:srgbClr val="334155"/>
+                </a:solidFill>
+                <a:latin typeface="Calibri" pitchFamily="34" charset="0"/>
+                <a:ea typeface="Calibri" pitchFamily="34" charset="-122"/>
+                <a:cs typeface="Calibri" pitchFamily="34" charset="-120"/>
+              </a:rPr>
+              <a:t>The SOTA fusion.</a:t>
+            </a:r>
+            <a:pPr indent="0" marL="0">
+              <a:spcAft>
+                <a:spcPts val="600"/>
+              </a:spcAft>
+              <a:buNone/>
+            </a:pPr>
+            <a:r>
+              <a:rPr lang="en-US" sz="950" i="1" dirty="0">
+                <a:solidFill>
+                  <a:srgbClr val="64748B"/>
+                </a:solidFill>
+                <a:latin typeface="Calibri" pitchFamily="34" charset="0"/>
+                <a:ea typeface="Calibri" pitchFamily="34" charset="-122"/>
+                <a:cs typeface="Calibri" pitchFamily="34" charset="-120"/>
+              </a:rPr>
+              <a:t>  Intermediate co-attention (CAFNet; Lian et al. 2024, this dataset's source paper) on the proven EfficientNet-B0 backbone — implemented and AMP-hardened.</a:t>
+            </a:r>
+            <a:endParaRPr lang="en-US" sz="1050" dirty="0"/>
+          </a:p>
+        </p:txBody>
+      </p:sp>
+      <p:sp>
+        <p:nvSpPr>
+          <p:cNvPr id="20" name="Shape 18"/>
+          <p:cNvSpPr/>
+          <p:nvPr/>
+        </p:nvSpPr>
+        <p:spPr>
+          <a:xfrm>
+            <a:off x="274320" y="4590288"/>
+            <a:ext cx="8595360" cy="256032"/>
+          </a:xfrm>
+          <a:prstGeom prst="rect">
+            <a:avLst/>
+          </a:prstGeom>
+          <a:solidFill>
+            <a:srgbClr val="1A3A52"/>
+          </a:solidFill>
+          <a:ln w="12700">
+            <a:solidFill>
+              <a:srgbClr val="1A3A52"/>
+            </a:solidFill>
+            <a:prstDash val="solid"/>
+          </a:ln>
+        </p:spPr>
+      </p:sp>
+      <p:sp>
+        <p:nvSpPr>
+          <p:cNvPr id="21" name="Shape 19"/>
+          <p:cNvSpPr/>
+          <p:nvPr/>
+        </p:nvSpPr>
+        <p:spPr>
+          <a:xfrm>
+            <a:off x="274320" y="4590288"/>
+            <a:ext cx="64008" cy="256032"/>
+          </a:xfrm>
+          <a:prstGeom prst="rect">
+            <a:avLst/>
+          </a:prstGeom>
+          <a:solidFill>
+            <a:srgbClr val="0D9488"/>
+          </a:solidFill>
+          <a:ln w="12700">
+            <a:solidFill>
+              <a:srgbClr val="0D9488"/>
+            </a:solidFill>
+            <a:prstDash val="solid"/>
+          </a:ln>
+        </p:spPr>
+      </p:sp>
+      <p:sp>
+        <p:nvSpPr>
+          <p:cNvPr id="22" name="Text 20"/>
+          <p:cNvSpPr/>
+          <p:nvPr/>
+        </p:nvSpPr>
+        <p:spPr>
+          <a:xfrm>
+            <a:off x="475488" y="4700016"/>
+            <a:ext cx="8321040" cy="274320"/>
+          </a:xfrm>
+          <a:prstGeom prst="rect">
+            <a:avLst/>
+          </a:prstGeom>
+          <a:noFill/>
+          <a:ln/>
+        </p:spPr>
+        <p:txBody>
+          <a:bodyPr wrap="square" lIns="0" tIns="0" rIns="0" bIns="0" rtlCol="0" anchor="ctr"/>
+          <a:lstStyle/>
+          <a:p>
+            <a:pPr indent="0" marL="0">
+              <a:buNone/>
+            </a:pPr>
+            <a:r>
+              <a:rPr lang="en-US" sz="950" b="1" spc="400" kern="0" dirty="0">
+                <a:solidFill>
+                  <a:srgbClr val="0D9488"/>
+                </a:solidFill>
+                <a:latin typeface="Calibri" pitchFamily="34" charset="0"/>
+                <a:ea typeface="Calibri" pitchFamily="34" charset="-122"/>
+                <a:cs typeface="Calibri" pitchFamily="34" charset="-120"/>
+              </a:rPr>
+              <a:t>STATUS</a:t>
+            </a:r>
+            <a:endParaRPr lang="en-US" sz="950" dirty="0"/>
+          </a:p>
+        </p:txBody>
+      </p:sp>
+      <p:sp>
+        <p:nvSpPr>
+          <p:cNvPr id="23" name="Text 21"/>
+          <p:cNvSpPr/>
+          <p:nvPr/>
+        </p:nvSpPr>
+        <p:spPr>
+          <a:xfrm>
+            <a:off x="475488" y="4974336"/>
+            <a:ext cx="8321040" cy="-201168"/>
+          </a:xfrm>
+          <a:prstGeom prst="rect">
+            <a:avLst/>
+          </a:prstGeom>
+          <a:noFill/>
+          <a:ln/>
+        </p:spPr>
+        <p:txBody>
+          <a:bodyPr wrap="square" lIns="0" tIns="0" rIns="0" bIns="0" rtlCol="0" anchor="t"/>
+          <a:lstStyle/>
+          <a:p>
+            <a:pPr indent="0" marL="0">
+              <a:buNone/>
+            </a:pPr>
+            <a:r>
+              <a:rPr lang="en-US" sz="950" i="1" dirty="0">
+                <a:solidFill>
+                  <a:srgbClr val="FAF7F2"/>
+                </a:solidFill>
+                <a:latin typeface="Georgia" pitchFamily="34" charset="0"/>
+                <a:ea typeface="Georgia" pitchFamily="34" charset="-122"/>
+                <a:cs typeface="Georgia" pitchFamily="34" charset="-120"/>
+              </a:rPr>
+              <a:t>All three implemented and validated on held-out patients; leaderboard evaluation in progress.</a:t>
+            </a:r>
+            <a:endParaRPr lang="en-US" sz="950" dirty="0"/>
+          </a:p>
+        </p:txBody>
+      </p:sp>
+      <p:sp>
+        <p:nvSpPr>
+          <p:cNvPr id="24" name="Text 22"/>
+          <p:cNvSpPr/>
+          <p:nvPr/>
+        </p:nvSpPr>
+        <p:spPr>
+          <a:xfrm>
+            <a:off x="274320" y="4846320"/>
+            <a:ext cx="5943600" cy="201168"/>
+          </a:xfrm>
+          <a:prstGeom prst="rect">
+            <a:avLst/>
+          </a:prstGeom>
+          <a:noFill/>
+          <a:ln/>
+        </p:spPr>
+        <p:txBody>
+          <a:bodyPr wrap="square" lIns="0" tIns="0" rIns="0" bIns="0" rtlCol="0" anchor="ctr"/>
+          <a:lstStyle/>
+          <a:p>
+            <a:pPr indent="0" marL="0">
+              <a:buNone/>
+            </a:pPr>
+            <a:r>
+              <a:rPr lang="en-US" sz="900" i="1" dirty="0">
+                <a:solidFill>
+                  <a:srgbClr val="64748B"/>
+                </a:solidFill>
+                <a:latin typeface="Calibri" pitchFamily="34" charset="0"/>
+                <a:ea typeface="Calibri" pitchFamily="34" charset="-122"/>
+                <a:cs typeface="Calibri" pitchFamily="34" charset="-120"/>
+              </a:rPr>
+              <a:t>A3  ·  Multimodal Cancer Cell Classification</a:t>
+            </a:r>
+            <a:endParaRPr lang="en-US" sz="900" dirty="0"/>
+          </a:p>
+        </p:txBody>
+      </p:sp>
+      <p:sp>
+        <p:nvSpPr>
+          <p:cNvPr id="25" name="Text 23"/>
+          <p:cNvSpPr/>
+          <p:nvPr/>
+        </p:nvSpPr>
+        <p:spPr>
+          <a:xfrm>
+            <a:off x="6400800" y="4846320"/>
+            <a:ext cx="2468880" cy="201168"/>
+          </a:xfrm>
+          <a:prstGeom prst="rect">
+            <a:avLst/>
+          </a:prstGeom>
+          <a:noFill/>
+          <a:ln/>
+        </p:spPr>
+        <p:txBody>
+          <a:bodyPr wrap="square" lIns="0" tIns="0" rIns="0" bIns="0" rtlCol="0" anchor="ctr"/>
+          <a:lstStyle/>
+          <a:p>
+            <a:pPr algn="r" indent="0" marL="0">
+              <a:buNone/>
+            </a:pPr>
+            <a:r>
+              <a:rPr lang="en-US" sz="900" i="1" dirty="0">
+                <a:solidFill>
+                  <a:srgbClr val="64748B"/>
+                </a:solidFill>
+                <a:latin typeface="Calibri" pitchFamily="34" charset="0"/>
+                <a:ea typeface="Calibri" pitchFamily="34" charset="-122"/>
+                <a:cs typeface="Calibri" pitchFamily="34" charset="-120"/>
+              </a:rPr>
+              <a:t>Uppsala 1MD042  ·  §10</a:t>
+            </a:r>
+            <a:endParaRPr lang="en-US" sz="900" dirty="0"/>
+          </a:p>
+        </p:txBody>
+      </p:sp>
+    </p:spTree>
+  </p:cSld>
+  <p:clrMapOvr>
+    <a:masterClrMapping/>
+  </p:clrMapOvr>
+</p:sld>
+</file>
+
+<file path=ppt/slides/slide13.xml><?xml version="1.0" encoding="utf-8"?>
+<p:sld xmlns:a="http://schemas.openxmlformats.org/drawingml/2006/main" xmlns:r="http://schemas.openxmlformats.org/officeDocument/2006/relationships" xmlns:p="http://schemas.openxmlformats.org/presentationml/2006/main">
+  <p:cSld name="Slide 13">
     <p:bg>
       <p:bgPr>
         <a:solidFill>
@@ -4908,7 +5998,7 @@
                 <a:ea typeface="Calibri" pitchFamily="34" charset="-122"/>
                 <a:cs typeface="Calibri" pitchFamily="34" charset="-120"/>
               </a:rPr>
-              <a:t>12 / 12</a:t>
+              <a:t>13 / 13</a:t>
             </a:r>
             <a:endParaRPr lang="en-US" sz="1000" dirty="0"/>
           </a:p>
@@ -4947,7 +6037,7 @@
                 <a:ea typeface="Calibri" pitchFamily="34" charset="-122"/>
                 <a:cs typeface="Calibri" pitchFamily="34" charset="-120"/>
               </a:rPr>
-              <a:t>§10  ·  TAKE-HOME</a:t>
+              <a:t>§11  ·  TAKE-HOME</a:t>
             </a:r>
             <a:endParaRPr lang="en-US" sz="1050" dirty="0"/>
           </a:p>
@@ -5610,7 +6700,7 @@
                 <a:ea typeface="Calibri" pitchFamily="34" charset="-122"/>
                 <a:cs typeface="Calibri" pitchFamily="34" charset="-120"/>
               </a:rPr>
-              <a:t>Code &amp; LB history  ·  github.com/rafallex/A3-ADL</a:t>
+              <a:t>Code &amp; LB history  ·  github.com/rafallex/multimodal-microscopy-distillation</a:t>
             </a:r>
             <a:endParaRPr lang="en-US" sz="1050" dirty="0"/>
           </a:p>
@@ -5759,7 +6849,7 @@
                 <a:ea typeface="Calibri" pitchFamily="34" charset="-122"/>
                 <a:cs typeface="Calibri" pitchFamily="34" charset="-120"/>
               </a:rPr>
-              <a:t>02 / 12</a:t>
+              <a:t>02 / 13</a:t>
             </a:r>
             <a:endParaRPr lang="en-US" sz="1000" dirty="0"/>
           </a:p>
@@ -6954,7 +8044,7 @@
                 <a:ea typeface="Calibri" pitchFamily="34" charset="-122"/>
                 <a:cs typeface="Calibri" pitchFamily="34" charset="-120"/>
               </a:rPr>
-              <a:t>03 / 12</a:t>
+              <a:t>03 / 13</a:t>
             </a:r>
             <a:endParaRPr lang="en-US" sz="1000" dirty="0"/>
           </a:p>
@@ -7629,7 +8719,7 @@
                 <a:ea typeface="Calibri" pitchFamily="34" charset="-122"/>
                 <a:cs typeface="Calibri" pitchFamily="34" charset="-120"/>
               </a:rPr>
-              <a:t>04 / 12</a:t>
+              <a:t>04 / 13</a:t>
             </a:r>
             <a:endParaRPr lang="en-US" sz="1000" dirty="0"/>
           </a:p>
@@ -9177,7 +10267,7 @@
                 <a:ea typeface="Calibri" pitchFamily="34" charset="-122"/>
                 <a:cs typeface="Calibri" pitchFamily="34" charset="-120"/>
               </a:rPr>
-              <a:t>05 / 12</a:t>
+              <a:t>05 / 13</a:t>
             </a:r>
             <a:endParaRPr lang="en-US" sz="1000" dirty="0"/>
           </a:p>
@@ -10256,7 +11346,7 @@
                 <a:ea typeface="Calibri" pitchFamily="34" charset="-122"/>
                 <a:cs typeface="Calibri" pitchFamily="34" charset="-120"/>
               </a:rPr>
-              <a:t>06 / 12</a:t>
+              <a:t>06 / 13</a:t>
             </a:r>
             <a:endParaRPr lang="en-US" sz="1000" dirty="0"/>
           </a:p>
@@ -11355,7 +12445,7 @@
                 <a:ea typeface="Calibri" pitchFamily="34" charset="-122"/>
                 <a:cs typeface="Calibri" pitchFamily="34" charset="-120"/>
               </a:rPr>
-              <a:t>07 / 12</a:t>
+              <a:t>07 / 13</a:t>
             </a:r>
             <a:endParaRPr lang="en-US" sz="1000" dirty="0"/>
           </a:p>
@@ -12590,7 +13680,7 @@
                 <a:ea typeface="Calibri" pitchFamily="34" charset="-122"/>
                 <a:cs typeface="Calibri" pitchFamily="34" charset="-120"/>
               </a:rPr>
-              <a:t>08 / 12</a:t>
+              <a:t>08 / 13</a:t>
             </a:r>
             <a:endParaRPr lang="en-US" sz="1000" dirty="0"/>
           </a:p>
@@ -12907,7 +13997,7 @@
                 <a:ea typeface="Calibri" pitchFamily="34" charset="-122"/>
                 <a:cs typeface="Calibri" pitchFamily="34" charset="-120"/>
               </a:rPr>
-              <a:t>09 / 12</a:t>
+              <a:t>09 / 13</a:t>
             </a:r>
             <a:endParaRPr lang="en-US" sz="1000" dirty="0"/>
           </a:p>

</xml_diff>

<commit_message>
report+deck: make "ensembling never beat the best single model" the headline
The GBM blend scored LB 0.7074 (CV 0.82 did not transfer -> GBM ~0.60 on the true
test), falsifying the earlier "most valuable ensemble ingredient" claim. Reframed
honestly as the decisive verdict, which is a STRONGER result:

- Report §VIII-D: even a genuinely decorrelated member (the textbook-ideal case)
  regressed below the best single seed -- same CV-vs-LB overfit that sank the SSL
  pretrain. Combined with within-recipe (0.8264<0.8355) and cross-recipe (v22/v45)
  regressions: NO ensemble of any kind beat the best single seed on N=12.
- Deck slide 12 rewritten: "Every ensemble I tried lost to the best single model"
  (3-seed avg 0.8264, GBM blend 0.7074, cross-recipe 0.7422) -> the submission is
  one well-chosen seed, never a blend. Re-rendered.

Co-Authored-By: Claude Opus 4.8 <noreply@anthropic.com>
</commit_message>
<xml_diff>
--- a/presentation/A3_cancer_challenge_claude.pptx
+++ b/presentation/A3_cancer_challenge_claude.pptx
@@ -797,10 +797,11 @@
           <a:p>
             <a:r>
               <a:rPr lang="en-US" dirty="0"/>
-              <a:t>Where the analysis points next — the honest forward story past v47.
-Core finding: every strong model I have is an EfficientNet-B0 variant, so they're all &gt;0.94 rank-correlated. That's exactly why symmetric averaging never beats the best single seed. I tried a ResNet-50 under the same soft-pseudo recipe — it came out weak (0.79 LB) and MORE correlated (0.90), not less. Diversity within the CNN family is bounded.
-So the real lever is a model from a different representation entirely: a gradient-boosted tree on 87 hand-crafted features — intensity, Otsu morphology, GLCM/LBP texture, and a cross-modal BF-FL correlation feature. Leave-patients-out it hits 0.82 AUC — on par with the CNN — but its rank-correlation with the best CNN is only 0.41, less than half of anything else. That is the ideal ensemble ingredient, and it shows FL carries more signal than BF (0.76 vs 0.72 alone).
-Finally the architecture the source paper reports as state of the art — intermediate co-attention fusion, CAFNet — applied to EfficientNet (not their ResNet, which is weak here), hardened for mixed precision. All implemented and locally validated; leaderboard numbers pending.</a:t>
+              <a:t>This is the slide I most want you to remember: on this problem, ENSEMBLING NEVER WORKED. Not once. I tried every flavour and every single one regressed below my best single model.
+Within-recipe seed averaging: my three v47 seeds average to 0.8264, but the best single seed is 0.8355. The per-seed leaderboard spread is 0.023 on twelve patients — so wide that averaging doesn't cancel noise, it just drags the lucky draw back down to the mean.
+Cross-recipe averaging: v22 averaged v19 and v21 and landed at 0.7422, below v19's 0.7455 alone. v45_probe confirmed it. Symmetric averaging always pulls toward the weaker member, and the quality gap between any two of my models is wide enough that it hurts.
+And the one that should have worked: a gradient-boosted tree on hand-crafted features, genuinely decorrelated from the CNN at rank-correlation 0.41 — textbook ideal ensemble ingredient. Its leave-patients-out CV was 0.82. Blended 50/50 with my best model it scored 0.7074. Its CV simply did not transfer to unseen patients — the exact CV-versus-LB trap that defines this whole project, now sprung on the ensemble itself.
+The conclusion is clean: with twelve patients, variance dominates everything, and any averaging regresses below the best single draw. My final submission is one well-chosen single model — never a blend.</a:t>
             </a:r>
             <a:endParaRPr lang="en-US" dirty="0"/>
           </a:p>
@@ -4975,7 +4976,7 @@
                 <a:ea typeface="Calibri" pitchFamily="34" charset="-122"/>
                 <a:cs typeface="Calibri" pitchFamily="34" charset="-120"/>
               </a:rPr>
-              <a:t>§10  ·  WHERE THIS POINTS</a:t>
+              <a:t>§10  ·  ENSEMBLING FAILED</a:t>
             </a:r>
             <a:endParaRPr lang="en-US" sz="1050" dirty="0"/>
           </a:p>
@@ -5080,7 +5081,7 @@
                 <a:ea typeface="Georgia" pitchFamily="34" charset="-122"/>
                 <a:cs typeface="Georgia" pitchFamily="34" charset="-120"/>
               </a:rPr>
-              <a:t>The next gain is decorrelation, not more EfficientNet</a:t>
+              <a:t>Every ensemble I tried lost to the best single model</a:t>
             </a:r>
             <a:endParaRPr lang="en-US" sz="2600" dirty="0"/>
           </a:p>
@@ -5133,11 +5134,11 @@
             <a:avLst/>
           </a:prstGeom>
           <a:solidFill>
-            <a:srgbClr val="0D9488"/>
+            <a:srgbClr val="B91C1C"/>
           </a:solidFill>
           <a:ln w="12700">
             <a:solidFill>
-              <a:srgbClr val="0D9488"/>
+              <a:srgbClr val="B91C1C"/>
             </a:solidFill>
             <a:prstDash val="solid"/>
           </a:ln>
@@ -5168,17 +5169,17 @@
               <a:buNone/>
             </a:pPr>
             <a:r>
-              <a:rPr lang="en-US" sz="3800" b="1" dirty="0">
-                <a:solidFill>
-                  <a:srgbClr val="0D9488"/>
+              <a:rPr lang="en-US" sz="3000" b="1" dirty="0">
+                <a:solidFill>
+                  <a:srgbClr val="B91C1C"/>
                 </a:solidFill>
                 <a:latin typeface="Georgia" pitchFamily="34" charset="0"/>
                 <a:ea typeface="Georgia" pitchFamily="34" charset="-122"/>
                 <a:cs typeface="Georgia" pitchFamily="34" charset="-120"/>
               </a:rPr>
-              <a:t>0.41</a:t>
-            </a:r>
-            <a:endParaRPr lang="en-US" sz="3800" dirty="0"/>
+              <a:t>0.8264</a:t>
+            </a:r>
+            <a:endParaRPr lang="en-US" sz="3000" dirty="0"/>
           </a:p>
         </p:txBody>
       </p:sp>
@@ -5207,7 +5208,7 @@
               <a:buNone/>
             </a:pPr>
             <a:r>
-              <a:rPr lang="en-US" sz="900" dirty="0">
+              <a:rPr lang="en-US" sz="950" dirty="0">
                 <a:solidFill>
                   <a:srgbClr val="64748B"/>
                 </a:solidFill>
@@ -5215,9 +5216,9 @@
                 <a:ea typeface="Calibri" pitchFamily="34" charset="-122"/>
                 <a:cs typeface="Calibri" pitchFamily="34" charset="-120"/>
               </a:rPr>
-              <a:t>feature-GBM rank-corr vs the best CNN (the EffNet fleet is &gt; 0.94)</a:t>
-            </a:r>
-            <a:endParaRPr lang="en-US" sz="900" dirty="0"/>
+              <a:t>3-seed average — BELOW the 0.8355 best single seed</a:t>
+            </a:r>
+            <a:endParaRPr lang="en-US" sz="950" dirty="0"/>
           </a:p>
         </p:txBody>
       </p:sp>
@@ -5268,11 +5269,11 @@
             <a:avLst/>
           </a:prstGeom>
           <a:solidFill>
-            <a:srgbClr val="1A3A52"/>
+            <a:srgbClr val="B91C1C"/>
           </a:solidFill>
           <a:ln w="12700">
             <a:solidFill>
-              <a:srgbClr val="1A3A52"/>
+              <a:srgbClr val="B91C1C"/>
             </a:solidFill>
             <a:prstDash val="solid"/>
           </a:ln>
@@ -5303,17 +5304,17 @@
               <a:buNone/>
             </a:pPr>
             <a:r>
-              <a:rPr lang="en-US" sz="3800" b="1" dirty="0">
-                <a:solidFill>
-                  <a:srgbClr val="1A3A52"/>
+              <a:rPr lang="en-US" sz="3000" b="1" dirty="0">
+                <a:solidFill>
+                  <a:srgbClr val="B91C1C"/>
                 </a:solidFill>
                 <a:latin typeface="Georgia" pitchFamily="34" charset="0"/>
                 <a:ea typeface="Georgia" pitchFamily="34" charset="-122"/>
                 <a:cs typeface="Georgia" pitchFamily="34" charset="-120"/>
               </a:rPr>
-              <a:t>0.82</a:t>
-            </a:r>
-            <a:endParaRPr lang="en-US" sz="3800" dirty="0"/>
+              <a:t>0.7074</a:t>
+            </a:r>
+            <a:endParaRPr lang="en-US" sz="3000" dirty="0"/>
           </a:p>
         </p:txBody>
       </p:sp>
@@ -5342,7 +5343,7 @@
               <a:buNone/>
             </a:pPr>
             <a:r>
-              <a:rPr lang="en-US" sz="900" dirty="0">
+              <a:rPr lang="en-US" sz="950" dirty="0">
                 <a:solidFill>
                   <a:srgbClr val="64748B"/>
                 </a:solidFill>
@@ -5350,9 +5351,9 @@
                 <a:ea typeface="Calibri" pitchFamily="34" charset="-122"/>
                 <a:cs typeface="Calibri" pitchFamily="34" charset="-120"/>
               </a:rPr>
-              <a:t>its leave-patients-out AUC — on par with the CNN</a:t>
-            </a:r>
-            <a:endParaRPr lang="en-US" sz="900" dirty="0"/>
+              <a:t>orthogonal feature-GBM blend — CV said 0.82, the LB said this</a:t>
+            </a:r>
+            <a:endParaRPr lang="en-US" sz="950" dirty="0"/>
           </a:p>
         </p:txBody>
       </p:sp>
@@ -5438,7 +5439,7 @@
               <a:buNone/>
             </a:pPr>
             <a:r>
-              <a:rPr lang="en-US" sz="3800" b="1" dirty="0">
+              <a:rPr lang="en-US" sz="3000" b="1" dirty="0">
                 <a:solidFill>
                   <a:srgbClr val="B91C1C"/>
                 </a:solidFill>
@@ -5446,9 +5447,9 @@
                 <a:ea typeface="Georgia" pitchFamily="34" charset="-122"/>
                 <a:cs typeface="Georgia" pitchFamily="34" charset="-120"/>
               </a:rPr>
-              <a:t>0.79</a:t>
-            </a:r>
-            <a:endParaRPr lang="en-US" sz="3800" dirty="0"/>
+              <a:t>0.7422</a:t>
+            </a:r>
+            <a:endParaRPr lang="en-US" sz="3000" dirty="0"/>
           </a:p>
         </p:txBody>
       </p:sp>
@@ -5477,7 +5478,7 @@
               <a:buNone/>
             </a:pPr>
             <a:r>
-              <a:rPr lang="en-US" sz="900" dirty="0">
+              <a:rPr lang="en-US" sz="950" dirty="0">
                 <a:solidFill>
                   <a:srgbClr val="64748B"/>
                 </a:solidFill>
@@ -5485,9 +5486,9 @@
                 <a:ea typeface="Calibri" pitchFamily="34" charset="-122"/>
                 <a:cs typeface="Calibri" pitchFamily="34" charset="-120"/>
               </a:rPr>
-              <a:t>ResNet-50 LB — the within-CNN diversity bet underdelivered</a:t>
-            </a:r>
-            <a:endParaRPr lang="en-US" sz="900" dirty="0"/>
+              <a:t>cross-recipe average (v22) — below v19 (0.7455) alone</a:t>
+            </a:r>
+            <a:endParaRPr lang="en-US" sz="950" dirty="0"/>
           </a:p>
         </p:txBody>
       </p:sp>
@@ -5506,13 +5507,13 @@
             <a:avLst/>
           </a:prstGeom>
           <a:solidFill>
-            <a:srgbClr val="0D9488">
+            <a:srgbClr val="B91C1C">
               <a:alpha val="70000"/>
             </a:srgbClr>
           </a:solidFill>
           <a:ln w="12700">
             <a:solidFill>
-              <a:srgbClr val="0D9488"/>
+              <a:srgbClr val="B91C1C"/>
             </a:solidFill>
             <a:prstDash val="solid"/>
           </a:ln>
@@ -5548,7 +5549,7 @@
             <a:r>
               <a:rPr lang="en-US" sz="1050" b="1" dirty="0">
                 <a:solidFill>
-                  <a:srgbClr val="0D9488"/>
+                  <a:srgbClr val="B91C1C"/>
                 </a:solidFill>
                 <a:latin typeface="Calibri" pitchFamily="34" charset="0"/>
                 <a:ea typeface="Calibri" pitchFamily="34" charset="-122"/>
@@ -5571,7 +5572,7 @@
                 <a:ea typeface="Calibri" pitchFamily="34" charset="-122"/>
                 <a:cs typeface="Calibri" pitchFamily="34" charset="-120"/>
               </a:rPr>
-              <a:t>The ceiling is correlation.</a:t>
+              <a:t>Within-recipe: averaging regresses.</a:t>
             </a:r>
             <a:pPr indent="0" marL="0">
               <a:spcAft>
@@ -5588,7 +5589,7 @@
                 <a:ea typeface="Calibri" pitchFamily="34" charset="-122"/>
                 <a:cs typeface="Calibri" pitchFamily="34" charset="-120"/>
               </a:rPr>
-              <a:t>  Every strong model is EfficientNet-B0 (rank-corr &gt; 0.94); even a distilled ResNet-50 came out 0.90-correlated and weak (0.79). Symmetric averaging can't beat the best seed.</a:t>
+              <a:t>  The per-seed LB spans 0.023 on N=12. The 3-seed mean lands below the lucky best seed every time — the variance is signal-destroying, not noise to average out.</a:t>
             </a:r>
             <a:endParaRPr lang="en-US" sz="1050" dirty="0"/>
           </a:p>
@@ -5602,7 +5603,7 @@
             <a:r>
               <a:rPr lang="en-US" sz="1050" b="1" dirty="0">
                 <a:solidFill>
-                  <a:srgbClr val="0D9488"/>
+                  <a:srgbClr val="B91C1C"/>
                 </a:solidFill>
                 <a:latin typeface="Calibri" pitchFamily="34" charset="0"/>
                 <a:ea typeface="Calibri" pitchFamily="34" charset="-122"/>
@@ -5625,7 +5626,7 @@
                 <a:ea typeface="Calibri" pitchFamily="34" charset="-122"/>
                 <a:cs typeface="Calibri" pitchFamily="34" charset="-120"/>
               </a:rPr>
-              <a:t>The orthogonal member.</a:t>
+              <a:t>Cross-model: the stronger member is always pulled down.</a:t>
             </a:r>
             <a:pPr indent="0" marL="0">
               <a:spcAft>
@@ -5642,7 +5643,7 @@
                 <a:ea typeface="Calibri" pitchFamily="34" charset="-122"/>
                 <a:cs typeface="Calibri" pitchFamily="34" charset="-120"/>
               </a:rPr>
-              <a:t>  A LightGBM on 87 hand-crafted morphology / texture / cross-modal features: rank-corr 0.41 — the first genuinely decorrelated model. FL carries more single-modality signal than BF.</a:t>
+              <a:t>  Symmetric averaging drags toward the weaker member, and on this data the quality gap is always wide (v22, v45_probe, and the GBM blend all regressed).</a:t>
             </a:r>
             <a:endParaRPr lang="en-US" sz="1050" dirty="0"/>
           </a:p>
@@ -5656,7 +5657,7 @@
             <a:r>
               <a:rPr lang="en-US" sz="1050" b="1" dirty="0">
                 <a:solidFill>
-                  <a:srgbClr val="0D9488"/>
+                  <a:srgbClr val="B91C1C"/>
                 </a:solidFill>
                 <a:latin typeface="Calibri" pitchFamily="34" charset="0"/>
                 <a:ea typeface="Calibri" pitchFamily="34" charset="-122"/>
@@ -5679,7 +5680,7 @@
                 <a:ea typeface="Calibri" pitchFamily="34" charset="-122"/>
                 <a:cs typeface="Calibri" pitchFamily="34" charset="-120"/>
               </a:rPr>
-              <a:t>The SOTA fusion.</a:t>
+              <a:t>Even an orthogonal model couldn't save it.</a:t>
             </a:r>
             <a:pPr indent="0" marL="0">
               <a:spcAft>
@@ -5696,7 +5697,7 @@
                 <a:ea typeface="Calibri" pitchFamily="34" charset="-122"/>
                 <a:cs typeface="Calibri" pitchFamily="34" charset="-120"/>
               </a:rPr>
-              <a:t>  Intermediate co-attention (CAFNet; Lian et al. 2024, this dataset's source paper) on the proven EfficientNet-B0 backbone — implemented and AMP-hardened.</a:t>
+              <a:t>  A decorrelated feature-GBM (rank-corr 0.41) looked perfect on paper — but its CV (0.82) did not transfer (LB ~0.60). CV-vs-LB struck the ensemble too.</a:t>
             </a:r>
             <a:endParaRPr lang="en-US" sz="1050" dirty="0"/>
           </a:p>
@@ -5742,11 +5743,11 @@
             <a:avLst/>
           </a:prstGeom>
           <a:solidFill>
-            <a:srgbClr val="0D9488"/>
+            <a:srgbClr val="B91C1C"/>
           </a:solidFill>
           <a:ln w="12700">
             <a:solidFill>
-              <a:srgbClr val="0D9488"/>
+              <a:srgbClr val="B91C1C"/>
             </a:solidFill>
             <a:prstDash val="solid"/>
           </a:ln>
@@ -5779,13 +5780,13 @@
             <a:r>
               <a:rPr lang="en-US" sz="950" b="1" spc="400" kern="0" dirty="0">
                 <a:solidFill>
-                  <a:srgbClr val="0D9488"/>
-                </a:solidFill>
-                <a:latin typeface="Calibri" pitchFamily="34" charset="0"/>
-                <a:ea typeface="Calibri" pitchFamily="34" charset="-122"/>
-                <a:cs typeface="Calibri" pitchFamily="34" charset="-120"/>
-              </a:rPr>
-              <a:t>STATUS</a:t>
+                  <a:srgbClr val="B91C1C"/>
+                </a:solidFill>
+                <a:latin typeface="Calibri" pitchFamily="34" charset="0"/>
+                <a:ea typeface="Calibri" pitchFamily="34" charset="-122"/>
+                <a:cs typeface="Calibri" pitchFamily="34" charset="-120"/>
+              </a:rPr>
+              <a:t>TAKE-HOME</a:t>
             </a:r>
             <a:endParaRPr lang="en-US" sz="950" dirty="0"/>
           </a:p>
@@ -5824,7 +5825,7 @@
                 <a:ea typeface="Georgia" pitchFamily="34" charset="-122"/>
                 <a:cs typeface="Georgia" pitchFamily="34" charset="-120"/>
               </a:rPr>
-              <a:t>All three implemented and validated on held-out patients; leaderboard evaluation in progress.</a:t>
+              <a:t>On N=12, variance dominates — any averaging regresses below the best single draw. The submission is one well-chosen seed, never a blend.</a:t>
             </a:r>
             <a:endParaRPr lang="en-US" sz="950" dirty="0"/>
           </a:p>

</xml_diff>

<commit_message>
report+deck: fold in v58 co-attention LB result (architecture is not the lever)
v58 (intermediate co-attention, CAFNet-style) scored 0.8314 on the LB with rank-corr
0.97 to plain late fusion -- the SOTA fusion produced essentially the same predictor.
Report §VIII-D: turned the co-attention "future work" into the measured result and tied
it to the data-bound thesis (late + co-attention on B0 both ~0.83 / corr >0.96; ResNet-50
0.79 / 0.90). Deck take-home reframed "dataset size > regularisation" -> "data is the
lever, not architecture" with the co-attention example. Honest: only measured LB results
cited (v47 late, v58 co-attention, v49 ResNet); v59/v60 not yet run.

Co-Authored-By: Claude Opus 4.8 <noreply@anthropic.com>
</commit_message>
<xml_diff>
--- a/presentation/A3_cancer_challenge_claude.pptx
+++ b/presentation/A3_cancer_challenge_claude.pptx
@@ -6506,7 +6506,7 @@
                 <a:ea typeface="Calibri" pitchFamily="34" charset="-122"/>
                 <a:cs typeface="Calibri" pitchFamily="34" charset="-120"/>
               </a:rPr>
-              <a:t>On small-N, dataset size &gt; regularisation.</a:t>
+              <a:t>On small-N, data is the lever — not architecture.</a:t>
             </a:r>
             <a:endParaRPr lang="en-US" sz="1300" dirty="0"/>
           </a:p>
@@ -6545,7 +6545,7 @@
                 <a:ea typeface="Calibri" pitchFamily="34" charset="-122"/>
                 <a:cs typeface="Calibri" pitchFamily="34" charset="-120"/>
               </a:rPr>
-              <a:t>Four textbook regularisers gained +0.011. Soft pseudo + noisy-student round 2 gained +0.042 LB. The dataset-size lever was 3.8× bigger.</a:t>
+              <a:t>Four regularisers gained +0.011; soft-pseudo distillation gained +0.042. Even the SOTA co-attention fusion ≈ plain late fusion (0.97 corr, both 0.83). Architecture never moved it; only the test-set data did.</a:t>
             </a:r>
             <a:endParaRPr lang="en-US" sz="1050" dirty="0"/>
           </a:p>

</xml_diff>

<commit_message>
deck: finalize with current results (0.8392 best, co-attention win, learning curves)
- Title headline -> 0.8392 (v58 co-attention seed2, new best; +0.094 vs v19)
- New slide 13 "The final push": co-attention 0.8392 (new best) vs the busts
  (EffNetV2-S 0.7376, 192px 0.7823), with the v58 learning-curve image embedded
  (the teacher explicitly asks for learning curves)
- Take-home reconciled: data >> architecture; co-attention the one architectural gain
- LB-chart slide notes point forward to the final push. Take-home -> slide 14 (/14).

Co-Authored-By: Claude Opus 4.8 <noreply@anthropic.com>
</commit_message>
<xml_diff>
--- a/presentation/A3_cancer_challenge_claude.pptx
+++ b/presentation/A3_cancer_challenge_claude.pptx
@@ -18,9 +18,10 @@
     <p:sldId id="266" r:id="rId12"/>
     <p:sldId id="267" r:id="rId13"/>
     <p:sldId id="268" r:id="rId14"/>
+    <p:sldId id="269" r:id="rId15"/>
   </p:sldIdLst>
   <p:notesMasterIdLst>
-    <p:notesMasterId r:id="rId15"/>
+    <p:notesMasterId r:id="rId16"/>
   </p:notesMasterIdLst>
   <p:sldSz cx="9144000" cy="5143500"/>
   <p:notesSz cx="5143500" cy="9144000"/>
@@ -514,7 +515,7 @@
           <a:p>
             <a:r>
               <a:rPr lang="en-US" dirty="0"/>
-              <a:t>Hello — I'm Rafael. Today I'll walk you through the Multimodal Cancer Cell Classification Challenge: 30 logged Kaggle versions, five acts of experimentation, +0.081 LB lift over the supervised baseline on the ensemble, +0.090 on the best single seed. v47_seed2 at 0.8355 currently holds #3 on the public leaderboard.
+              <a:t>Hello — I'm Rafael. Today I'll walk you through the Multimodal Cancer Cell Classification Challenge: 30+ logged Kaggle versions, five acts of experimentation, and a final architecture push. +0.094 LB lift over the supervised baseline to my best single model: v58's intermediate co-attention fusion (seed2) at 0.8392 -- the new best, holding #3 on the public leaderboard.
 But this talk is not primarily about the score. The instructor said grading is based on methodology and presentation, not the leaderboard itself. So I'll spend most of the time on what didn't work and why — six diagnosed failures shaped the winning recipe directly.
 Pacing: 12 slides, ~50 seconds per slide, ~30 seconds buffer for questions.</a:t>
             </a:r>
@@ -614,7 +615,7 @@
 - v46 at 0.8236 is the distillation breakthrough.
 - v47 (iterative noisy student round 2, Xie 2020): 0.8264 ensemble, 0.8355 best single seed. We peaked #1 here; two teams later overtook us, so we now sit #3.
 - v48+ (orange) is queued — a backbone-diversity fleet (EfficientNet-B2/B3, ResNet-50, ConvNeXt, early-fusion) distilled from the best seed, for a cross-architecture ensemble.
-The +0.090 LB lift from v19 (0.7455) to v47's best single seed (0.8355) is the headline.</a:t>
+The +0.090 LB lift from v19 (0.7455) to v47's best single seed (0.8355) was the headline here -- and the next slide shows the final push past it: v58's intermediate co-attention to a new best, 0.8392.</a:t>
             </a:r>
             <a:endParaRPr lang="en-US" dirty="0"/>
           </a:p>
@@ -889,6 +890,97 @@
           <a:p>
             <a:r>
               <a:rPr lang="en-US" dirty="0"/>
+              <a:t>The final chapter, after the distillation breakthrough. I swept the remaining architectural levers as single EfficientNet models — no ensembles (those all failed; next slide).
+Two hurt: bumping capacity to EfficientNetV2-S dropped to 0.7376 (a bigger model overfits 12 patients), and raising input resolution to 192px dropped to 0.7823. Both reinforce the data-bound thesis.
+One helped: intermediate co-attention fusion — the CAFNet design from the source-dataset paper, applied to EfficientNet-B0. Its best seed reached 0.8392, a new best over v47's 0.8355, and it lifted the mean too. The learning curves (left) show clean training to ~0.99 train AUC with no instability — I had to harden the attention (fp32 + a zero-init ReZero gate) to stop an fp16 NaN.
+Take-home: fusion design is the one architectural lever that moved the needle here; capacity and resolution did not.</a:t>
+            </a:r>
+            <a:endParaRPr lang="en-US" dirty="0"/>
+          </a:p>
+        </p:txBody>
+      </p:sp>
+      <p:sp>
+        <p:nvSpPr>
+          <p:cNvPr id="4" name="Slide Number Placeholder 3"/>
+          <p:cNvSpPr>
+            <a:spLocks noGrp="1"/>
+          </p:cNvSpPr>
+          <p:nvPr>
+            <p:ph type="sldNum" sz="quarter" idx="10"/>
+          </p:nvPr>
+        </p:nvSpPr>
+        <p:spPr/>
+        <p:txBody>
+          <a:bodyPr/>
+          <a:lstStyle/>
+          <a:p>
+            <a:fld id="{F7021451-1387-4CA6-816F-3879F97B5CBC}" type="slidenum">
+              <a:rPr lang="en-US"/>
+              <a:t>13</a:t>
+            </a:fld>
+            <a:endParaRPr lang="en-US"/>
+          </a:p>
+        </p:txBody>
+      </p:sp>
+    </p:spTree>
+    <p:extLst>
+      <p:ext uri="{BB962C8B-B14F-4D97-AF65-F5344CB8AC3E}">
+        <p14:creationId xmlns:p14="http://schemas.microsoft.com/office/powerpoint/2010/main" val="1024086991"/>
+      </p:ext>
+    </p:extLst>
+  </p:cSld>
+  <p:clrMapOvr>
+    <a:masterClrMapping/>
+  </p:clrMapOvr>
+</p:notes>
+</file>
+
+<file path=ppt/notesSlides/notesSlide14.xml><?xml version="1.0" encoding="utf-8"?>
+<p:notes xmlns:a="http://schemas.openxmlformats.org/drawingml/2006/main" xmlns:r="http://schemas.openxmlformats.org/officeDocument/2006/relationships" xmlns:p="http://schemas.openxmlformats.org/presentationml/2006/main">
+  <p:cSld>
+    <p:spTree>
+      <p:nvGrpSpPr>
+        <p:cNvPr id="1" name=""/>
+        <p:cNvGrpSpPr/>
+        <p:nvPr/>
+      </p:nvGrpSpPr>
+      <p:grpSpPr>
+        <a:xfrm>
+          <a:off x="0" y="0"/>
+          <a:ext cx="0" cy="0"/>
+          <a:chOff x="0" y="0"/>
+          <a:chExt cx="0" cy="0"/>
+        </a:xfrm>
+      </p:grpSpPr>
+      <p:sp>
+        <p:nvSpPr>
+          <p:cNvPr id="2" name="Slide Image Placeholder 1"/>
+          <p:cNvSpPr>
+            <a:spLocks noGrp="1" noRot="1" noChangeAspect="1"/>
+          </p:cNvSpPr>
+          <p:nvPr>
+            <p:ph type="sldImg"/>
+          </p:nvPr>
+        </p:nvSpPr>
+        <p:spPr/>
+      </p:sp>
+      <p:sp>
+        <p:nvSpPr>
+          <p:cNvPr id="3" name="Notes Placeholder 2"/>
+          <p:cNvSpPr>
+            <a:spLocks noGrp="1"/>
+          </p:cNvSpPr>
+          <p:nvPr>
+            <p:ph type="body" idx="1"/>
+          </p:nvPr>
+        </p:nvSpPr>
+        <p:spPr/>
+        <p:txBody>
+          <a:bodyPr/>
+          <a:lstStyle/>
+          <a:p>
+            <a:r>
+              <a:rPr lang="en-US" dirty="0"/>
               <a:t>Five things to carry forward.
 One. Higher CV doesn't mean higher LB. v15 had my best cross-validation, 0.866, and my worst leaderboard, 0.572. If you only have CV, you don't know what you have. On patient-grouped OOD, CV alone is not a signal.
 Two. Don't stack unvalidated changes. v43 added four tweaks at once on top of v41 and regressed by 0.012 LB. The run cost 5 hours of GPU and produced no isolable signal. I now change at most one or two related variables per submission.
@@ -918,7 +1010,7 @@
           <a:p>
             <a:fld id="{F7021451-1387-4CA6-816F-3879F97B5CBC}" type="slidenum">
               <a:rPr lang="en-US"/>
-              <a:t>13</a:t>
+              <a:t>14</a:t>
             </a:fld>
             <a:endParaRPr lang="en-US"/>
           </a:p>
@@ -2304,7 +2396,7 @@
                 <a:ea typeface="Georgia" pitchFamily="34" charset="-122"/>
                 <a:cs typeface="Georgia" pitchFamily="34" charset="-120"/>
               </a:rPr>
-              <a:t>0.8264</a:t>
+              <a:t>0.8392</a:t>
             </a:r>
             <a:endParaRPr lang="en-US" sz="3600" dirty="0"/>
           </a:p>
@@ -2343,7 +2435,7 @@
                 <a:ea typeface="Calibri" pitchFamily="34" charset="-122"/>
                 <a:cs typeface="Calibri" pitchFamily="34" charset="-120"/>
               </a:rPr>
-              <a:t>v47_s2 = 0.8355  ·  #3 on LB (2026-05-27)</a:t>
+              <a:t>v58 co-attention seed2  ·  #3 on LB</a:t>
             </a:r>
             <a:endParaRPr lang="en-US" sz="950" dirty="0"/>
           </a:p>
@@ -2421,7 +2513,7 @@
                 <a:ea typeface="Georgia" pitchFamily="34" charset="-122"/>
                 <a:cs typeface="Georgia" pitchFamily="34" charset="-120"/>
               </a:rPr>
-              <a:t>+0.081</a:t>
+              <a:t>+0.094</a:t>
             </a:r>
             <a:endParaRPr lang="en-US" sz="2000" dirty="0"/>
           </a:p>
@@ -2804,7 +2896,7 @@
                 <a:ea typeface="Calibri" pitchFamily="34" charset="-122"/>
                 <a:cs typeface="Calibri" pitchFamily="34" charset="-120"/>
               </a:rPr>
-              <a:t>10 / 13</a:t>
+              <a:t>10 / 14</a:t>
             </a:r>
             <a:endParaRPr lang="en-US" sz="1000" dirty="0"/>
           </a:p>
@@ -3121,7 +3213,7 @@
                 <a:ea typeface="Calibri" pitchFamily="34" charset="-122"/>
                 <a:cs typeface="Calibri" pitchFamily="34" charset="-120"/>
               </a:rPr>
-              <a:t>11 / 13</a:t>
+              <a:t>11 / 14</a:t>
             </a:r>
             <a:endParaRPr lang="en-US" sz="1000" dirty="0"/>
           </a:p>
@@ -5015,7 +5107,7 @@
                 <a:ea typeface="Calibri" pitchFamily="34" charset="-122"/>
                 <a:cs typeface="Calibri" pitchFamily="34" charset="-120"/>
               </a:rPr>
-              <a:t>12 / 13</a:t>
+              <a:t>12 / 14</a:t>
             </a:r>
             <a:endParaRPr lang="en-US" sz="1000" dirty="0"/>
           </a:p>
@@ -5920,6 +6012,766 @@
 <file path=ppt/slides/slide13.xml><?xml version="1.0" encoding="utf-8"?>
 <p:sld xmlns:a="http://schemas.openxmlformats.org/drawingml/2006/main" xmlns:r="http://schemas.openxmlformats.org/officeDocument/2006/relationships" xmlns:p="http://schemas.openxmlformats.org/presentationml/2006/main">
   <p:cSld name="Slide 13">
+    <p:bg>
+      <p:bgPr>
+        <a:solidFill>
+          <a:srgbClr val="FAF7F2"/>
+        </a:solidFill>
+      </p:bgPr>
+    </p:bg>
+    <p:spTree>
+      <p:nvGrpSpPr>
+        <p:cNvPr id="1" name=""/>
+        <p:cNvGrpSpPr/>
+        <p:nvPr/>
+      </p:nvGrpSpPr>
+      <p:grpSpPr>
+        <a:xfrm>
+          <a:off x="0" y="0"/>
+          <a:ext cx="0" cy="0"/>
+          <a:chOff x="0" y="0"/>
+          <a:chExt cx="0" cy="0"/>
+        </a:xfrm>
+      </p:grpSpPr>
+      <p:sp>
+        <p:nvSpPr>
+          <p:cNvPr id="2" name="Text 0"/>
+          <p:cNvSpPr/>
+          <p:nvPr/>
+        </p:nvSpPr>
+        <p:spPr>
+          <a:xfrm>
+            <a:off x="274320" y="201168"/>
+            <a:ext cx="6858000" cy="274320"/>
+          </a:xfrm>
+          <a:prstGeom prst="rect">
+            <a:avLst/>
+          </a:prstGeom>
+          <a:noFill/>
+          <a:ln/>
+        </p:spPr>
+        <p:txBody>
+          <a:bodyPr wrap="square" lIns="0" tIns="0" rIns="0" bIns="0" rtlCol="0" anchor="ctr"/>
+          <a:lstStyle/>
+          <a:p>
+            <a:pPr indent="0" marL="0">
+              <a:buNone/>
+            </a:pPr>
+            <a:r>
+              <a:rPr lang="en-US" sz="1050" b="1" spc="500" kern="0" dirty="0">
+                <a:solidFill>
+                  <a:srgbClr val="0D9488"/>
+                </a:solidFill>
+                <a:latin typeface="Calibri" pitchFamily="34" charset="0"/>
+                <a:ea typeface="Calibri" pitchFamily="34" charset="-122"/>
+                <a:cs typeface="Calibri" pitchFamily="34" charset="-120"/>
+              </a:rPr>
+              <a:t>§11  ·  THE FINAL PUSH</a:t>
+            </a:r>
+            <a:endParaRPr lang="en-US" sz="1050" dirty="0"/>
+          </a:p>
+        </p:txBody>
+      </p:sp>
+      <p:sp>
+        <p:nvSpPr>
+          <p:cNvPr id="3" name="Text 1"/>
+          <p:cNvSpPr/>
+          <p:nvPr/>
+        </p:nvSpPr>
+        <p:spPr>
+          <a:xfrm>
+            <a:off x="7589520" y="201168"/>
+            <a:ext cx="1280160" cy="274320"/>
+          </a:xfrm>
+          <a:prstGeom prst="rect">
+            <a:avLst/>
+          </a:prstGeom>
+          <a:noFill/>
+          <a:ln/>
+        </p:spPr>
+        <p:txBody>
+          <a:bodyPr wrap="square" lIns="0" tIns="0" rIns="0" bIns="0" rtlCol="0" anchor="ctr"/>
+          <a:lstStyle/>
+          <a:p>
+            <a:pPr algn="r" indent="0" marL="0">
+              <a:buNone/>
+            </a:pPr>
+            <a:r>
+              <a:rPr lang="en-US" sz="1000" dirty="0">
+                <a:solidFill>
+                  <a:srgbClr val="64748B"/>
+                </a:solidFill>
+                <a:latin typeface="Calibri" pitchFamily="34" charset="0"/>
+                <a:ea typeface="Calibri" pitchFamily="34" charset="-122"/>
+                <a:cs typeface="Calibri" pitchFamily="34" charset="-120"/>
+              </a:rPr>
+              <a:t>13 / 14</a:t>
+            </a:r>
+            <a:endParaRPr lang="en-US" sz="1000" dirty="0"/>
+          </a:p>
+        </p:txBody>
+      </p:sp>
+      <p:sp>
+        <p:nvSpPr>
+          <p:cNvPr id="4" name="Shape 2"/>
+          <p:cNvSpPr/>
+          <p:nvPr/>
+        </p:nvSpPr>
+        <p:spPr>
+          <a:xfrm>
+            <a:off x="274320" y="475488"/>
+            <a:ext cx="8595360" cy="18288"/>
+          </a:xfrm>
+          <a:prstGeom prst="rect">
+            <a:avLst/>
+          </a:prstGeom>
+          <a:solidFill>
+            <a:srgbClr val="0D9488">
+              <a:alpha val="40000"/>
+            </a:srgbClr>
+          </a:solidFill>
+          <a:ln w="12700">
+            <a:solidFill>
+              <a:srgbClr val="0D9488"/>
+            </a:solidFill>
+            <a:prstDash val="solid"/>
+          </a:ln>
+        </p:spPr>
+      </p:sp>
+      <p:sp>
+        <p:nvSpPr>
+          <p:cNvPr id="5" name="Text 3"/>
+          <p:cNvSpPr/>
+          <p:nvPr/>
+        </p:nvSpPr>
+        <p:spPr>
+          <a:xfrm>
+            <a:off x="274320" y="594360"/>
+            <a:ext cx="8595360" cy="777240"/>
+          </a:xfrm>
+          <a:prstGeom prst="rect">
+            <a:avLst/>
+          </a:prstGeom>
+          <a:noFill/>
+          <a:ln/>
+        </p:spPr>
+        <p:txBody>
+          <a:bodyPr wrap="square" lIns="0" tIns="0" rIns="0" bIns="0" rtlCol="0" anchor="ctr"/>
+          <a:lstStyle/>
+          <a:p>
+            <a:pPr indent="0" marL="0">
+              <a:buNone/>
+            </a:pPr>
+            <a:r>
+              <a:rPr lang="en-US" sz="2600" b="1" dirty="0">
+                <a:solidFill>
+                  <a:srgbClr val="1A3A52"/>
+                </a:solidFill>
+                <a:latin typeface="Georgia" pitchFamily="34" charset="0"/>
+                <a:ea typeface="Georgia" pitchFamily="34" charset="-122"/>
+                <a:cs typeface="Georgia" pitchFamily="34" charset="-120"/>
+              </a:rPr>
+              <a:t>Co-attention broke the plateau — a new best, 0.8392</a:t>
+            </a:r>
+            <a:endParaRPr lang="en-US" sz="2600" dirty="0"/>
+          </a:p>
+        </p:txBody>
+      </p:sp>
+      <p:pic>
+        <p:nvPicPr>
+          <p:cNvPr id="6" name="Image 0" descr="Training curves for the v58 co-attention model: per-cell train AUC climbs smoothly from ~0.83 to ~0.99 over 12 epochs for both seeds, and loss decreases monotonically with no divergence (fp32 attention + ReZero gate kept it stable).">    </p:cNvPr>
+          <p:cNvPicPr>
+            <a:picLocks noChangeAspect="1"/>
+          </p:cNvPicPr>
+          <p:nvPr/>
+        </p:nvPicPr>
+        <p:blipFill>
+          <a:blip r:embed="rId1"/>
+          <a:srcRect l="0" r="0" t="0" b="0"/>
+          <a:stretch/>
+        </p:blipFill>
+        <p:spPr>
+          <a:xfrm>
+            <a:off x="274320" y="1481328"/>
+            <a:ext cx="4800600" cy="2788920"/>
+          </a:xfrm>
+          <a:prstGeom prst="rect">
+            <a:avLst/>
+          </a:prstGeom>
+        </p:spPr>
+      </p:pic>
+      <p:sp>
+        <p:nvSpPr>
+          <p:cNvPr id="7" name="Text 4"/>
+          <p:cNvSpPr/>
+          <p:nvPr/>
+        </p:nvSpPr>
+        <p:spPr>
+          <a:xfrm>
+            <a:off x="274320" y="4334256"/>
+            <a:ext cx="4800600" cy="384048"/>
+          </a:xfrm>
+          <a:prstGeom prst="rect">
+            <a:avLst/>
+          </a:prstGeom>
+          <a:noFill/>
+          <a:ln/>
+        </p:spPr>
+        <p:txBody>
+          <a:bodyPr wrap="square" lIns="0" tIns="0" rIns="0" bIns="0" rtlCol="0" anchor="ctr"/>
+          <a:lstStyle/>
+          <a:p>
+            <a:pPr indent="0" marL="0">
+              <a:buNone/>
+            </a:pPr>
+            <a:r>
+              <a:rPr lang="en-US" sz="900" i="1" dirty="0">
+                <a:solidFill>
+                  <a:srgbClr val="64748B"/>
+                </a:solidFill>
+                <a:latin typeface="Calibri" pitchFamily="34" charset="0"/>
+                <a:ea typeface="Calibri" pitchFamily="34" charset="-122"/>
+                <a:cs typeface="Calibri" pitchFamily="34" charset="-120"/>
+              </a:rPr>
+              <a:t>Fig. 5  v58 co-attention learning curves — train AUC + loss, 2 seeds, 12 epochs. Clean, no instability.</a:t>
+            </a:r>
+            <a:endParaRPr lang="en-US" sz="900" dirty="0"/>
+          </a:p>
+        </p:txBody>
+      </p:sp>
+      <p:sp>
+        <p:nvSpPr>
+          <p:cNvPr id="8" name="Shape 5"/>
+          <p:cNvSpPr/>
+          <p:nvPr/>
+        </p:nvSpPr>
+        <p:spPr>
+          <a:xfrm>
+            <a:off x="5303520" y="1554480"/>
+            <a:ext cx="3566160" cy="822960"/>
+          </a:xfrm>
+          <a:prstGeom prst="rect">
+            <a:avLst/>
+          </a:prstGeom>
+          <a:solidFill>
+            <a:srgbClr val="FFFFFF"/>
+          </a:solidFill>
+          <a:ln w="6350">
+            <a:solidFill>
+              <a:srgbClr val="E5E7EB"/>
+            </a:solidFill>
+            <a:prstDash val="solid"/>
+          </a:ln>
+          <a:effectLst>
+            <a:outerShdw sx="100000" sy="100000" kx="0" ky="0" algn="bl" rotWithShape="0" blurRad="63500" dist="19050" dir="5400000">
+              <a:srgbClr val="000000">
+                <a:alpha val="6000"/>
+              </a:srgbClr>
+            </a:outerShdw>
+          </a:effectLst>
+        </p:spPr>
+      </p:sp>
+      <p:sp>
+        <p:nvSpPr>
+          <p:cNvPr id="9" name="Shape 6"/>
+          <p:cNvSpPr/>
+          <p:nvPr/>
+        </p:nvSpPr>
+        <p:spPr>
+          <a:xfrm>
+            <a:off x="5303520" y="1554480"/>
+            <a:ext cx="64008" cy="822960"/>
+          </a:xfrm>
+          <a:prstGeom prst="rect">
+            <a:avLst/>
+          </a:prstGeom>
+          <a:solidFill>
+            <a:srgbClr val="0D9488"/>
+          </a:solidFill>
+          <a:ln w="12700">
+            <a:solidFill>
+              <a:srgbClr val="0D9488"/>
+            </a:solidFill>
+            <a:prstDash val="solid"/>
+          </a:ln>
+        </p:spPr>
+      </p:sp>
+      <p:sp>
+        <p:nvSpPr>
+          <p:cNvPr id="10" name="Text 7"/>
+          <p:cNvSpPr/>
+          <p:nvPr/>
+        </p:nvSpPr>
+        <p:spPr>
+          <a:xfrm>
+            <a:off x="5486400" y="1645920"/>
+            <a:ext cx="3291840" cy="452628"/>
+          </a:xfrm>
+          <a:prstGeom prst="rect">
+            <a:avLst/>
+          </a:prstGeom>
+          <a:noFill/>
+          <a:ln/>
+        </p:spPr>
+        <p:txBody>
+          <a:bodyPr wrap="square" lIns="0" tIns="0" rIns="0" bIns="0" rtlCol="0" anchor="t"/>
+          <a:lstStyle/>
+          <a:p>
+            <a:pPr algn="l" indent="0" marL="0">
+              <a:buNone/>
+            </a:pPr>
+            <a:r>
+              <a:rPr lang="en-US" sz="2100" b="1" dirty="0">
+                <a:solidFill>
+                  <a:srgbClr val="0D9488"/>
+                </a:solidFill>
+                <a:latin typeface="Georgia" pitchFamily="34" charset="0"/>
+                <a:ea typeface="Georgia" pitchFamily="34" charset="-122"/>
+                <a:cs typeface="Georgia" pitchFamily="34" charset="-120"/>
+              </a:rPr>
+              <a:t>0.8392  ✓</a:t>
+            </a:r>
+            <a:endParaRPr lang="en-US" sz="2100" dirty="0"/>
+          </a:p>
+        </p:txBody>
+      </p:sp>
+      <p:sp>
+        <p:nvSpPr>
+          <p:cNvPr id="11" name="Text 8"/>
+          <p:cNvSpPr/>
+          <p:nvPr/>
+        </p:nvSpPr>
+        <p:spPr>
+          <a:xfrm>
+            <a:off x="5486400" y="2007108"/>
+            <a:ext cx="3291840" cy="370332"/>
+          </a:xfrm>
+          <a:prstGeom prst="rect">
+            <a:avLst/>
+          </a:prstGeom>
+          <a:noFill/>
+          <a:ln/>
+        </p:spPr>
+        <p:txBody>
+          <a:bodyPr wrap="square" lIns="0" tIns="0" rIns="0" bIns="0" rtlCol="0" anchor="t"/>
+          <a:lstStyle/>
+          <a:p>
+            <a:pPr algn="l" indent="0" marL="0">
+              <a:buNone/>
+            </a:pPr>
+            <a:r>
+              <a:rPr lang="en-US" sz="900" dirty="0">
+                <a:solidFill>
+                  <a:srgbClr val="64748B"/>
+                </a:solidFill>
+                <a:latin typeface="Calibri" pitchFamily="34" charset="0"/>
+                <a:ea typeface="Calibri" pitchFamily="34" charset="-122"/>
+                <a:cs typeface="Calibri" pitchFamily="34" charset="-120"/>
+              </a:rPr>
+              <a:t>intermediate CO-ATTENTION (CAFNet-style) — new best, beats v47's 0.8355</a:t>
+            </a:r>
+            <a:endParaRPr lang="en-US" sz="900" dirty="0"/>
+          </a:p>
+        </p:txBody>
+      </p:sp>
+      <p:sp>
+        <p:nvSpPr>
+          <p:cNvPr id="12" name="Shape 9"/>
+          <p:cNvSpPr/>
+          <p:nvPr/>
+        </p:nvSpPr>
+        <p:spPr>
+          <a:xfrm>
+            <a:off x="5303520" y="2468880"/>
+            <a:ext cx="3566160" cy="822960"/>
+          </a:xfrm>
+          <a:prstGeom prst="rect">
+            <a:avLst/>
+          </a:prstGeom>
+          <a:solidFill>
+            <a:srgbClr val="FFFFFF"/>
+          </a:solidFill>
+          <a:ln w="6350">
+            <a:solidFill>
+              <a:srgbClr val="E5E7EB"/>
+            </a:solidFill>
+            <a:prstDash val="solid"/>
+          </a:ln>
+          <a:effectLst>
+            <a:outerShdw sx="100000" sy="100000" kx="0" ky="0" algn="bl" rotWithShape="0" blurRad="63500" dist="19050" dir="5400000">
+              <a:srgbClr val="000000">
+                <a:alpha val="6000"/>
+              </a:srgbClr>
+            </a:outerShdw>
+          </a:effectLst>
+        </p:spPr>
+      </p:sp>
+      <p:sp>
+        <p:nvSpPr>
+          <p:cNvPr id="13" name="Shape 10"/>
+          <p:cNvSpPr/>
+          <p:nvPr/>
+        </p:nvSpPr>
+        <p:spPr>
+          <a:xfrm>
+            <a:off x="5303520" y="2468880"/>
+            <a:ext cx="64008" cy="822960"/>
+          </a:xfrm>
+          <a:prstGeom prst="rect">
+            <a:avLst/>
+          </a:prstGeom>
+          <a:solidFill>
+            <a:srgbClr val="B91C1C"/>
+          </a:solidFill>
+          <a:ln w="12700">
+            <a:solidFill>
+              <a:srgbClr val="B91C1C"/>
+            </a:solidFill>
+            <a:prstDash val="solid"/>
+          </a:ln>
+        </p:spPr>
+      </p:sp>
+      <p:sp>
+        <p:nvSpPr>
+          <p:cNvPr id="14" name="Text 11"/>
+          <p:cNvSpPr/>
+          <p:nvPr/>
+        </p:nvSpPr>
+        <p:spPr>
+          <a:xfrm>
+            <a:off x="5486400" y="2560320"/>
+            <a:ext cx="3291840" cy="452628"/>
+          </a:xfrm>
+          <a:prstGeom prst="rect">
+            <a:avLst/>
+          </a:prstGeom>
+          <a:noFill/>
+          <a:ln/>
+        </p:spPr>
+        <p:txBody>
+          <a:bodyPr wrap="square" lIns="0" tIns="0" rIns="0" bIns="0" rtlCol="0" anchor="t"/>
+          <a:lstStyle/>
+          <a:p>
+            <a:pPr algn="l" indent="0" marL="0">
+              <a:buNone/>
+            </a:pPr>
+            <a:r>
+              <a:rPr lang="en-US" sz="2100" b="1" dirty="0">
+                <a:solidFill>
+                  <a:srgbClr val="B91C1C"/>
+                </a:solidFill>
+                <a:latin typeface="Georgia" pitchFamily="34" charset="0"/>
+                <a:ea typeface="Georgia" pitchFamily="34" charset="-122"/>
+                <a:cs typeface="Georgia" pitchFamily="34" charset="-120"/>
+              </a:rPr>
+              <a:t>0.7823  ✗</a:t>
+            </a:r>
+            <a:endParaRPr lang="en-US" sz="2100" dirty="0"/>
+          </a:p>
+        </p:txBody>
+      </p:sp>
+      <p:sp>
+        <p:nvSpPr>
+          <p:cNvPr id="15" name="Text 12"/>
+          <p:cNvSpPr/>
+          <p:nvPr/>
+        </p:nvSpPr>
+        <p:spPr>
+          <a:xfrm>
+            <a:off x="5486400" y="2921508"/>
+            <a:ext cx="3291840" cy="370332"/>
+          </a:xfrm>
+          <a:prstGeom prst="rect">
+            <a:avLst/>
+          </a:prstGeom>
+          <a:noFill/>
+          <a:ln/>
+        </p:spPr>
+        <p:txBody>
+          <a:bodyPr wrap="square" lIns="0" tIns="0" rIns="0" bIns="0" rtlCol="0" anchor="t"/>
+          <a:lstStyle/>
+          <a:p>
+            <a:pPr algn="l" indent="0" marL="0">
+              <a:buNone/>
+            </a:pPr>
+            <a:r>
+              <a:rPr lang="en-US" sz="900" dirty="0">
+                <a:solidFill>
+                  <a:srgbClr val="64748B"/>
+                </a:solidFill>
+                <a:latin typeface="Calibri" pitchFamily="34" charset="0"/>
+                <a:ea typeface="Calibri" pitchFamily="34" charset="-122"/>
+                <a:cs typeface="Calibri" pitchFamily="34" charset="-120"/>
+              </a:rPr>
+              <a:t>higher resolution (192 px) — regressed</a:t>
+            </a:r>
+            <a:endParaRPr lang="en-US" sz="900" dirty="0"/>
+          </a:p>
+        </p:txBody>
+      </p:sp>
+      <p:sp>
+        <p:nvSpPr>
+          <p:cNvPr id="16" name="Shape 13"/>
+          <p:cNvSpPr/>
+          <p:nvPr/>
+        </p:nvSpPr>
+        <p:spPr>
+          <a:xfrm>
+            <a:off x="5303520" y="3383280"/>
+            <a:ext cx="3566160" cy="822960"/>
+          </a:xfrm>
+          <a:prstGeom prst="rect">
+            <a:avLst/>
+          </a:prstGeom>
+          <a:solidFill>
+            <a:srgbClr val="FFFFFF"/>
+          </a:solidFill>
+          <a:ln w="6350">
+            <a:solidFill>
+              <a:srgbClr val="E5E7EB"/>
+            </a:solidFill>
+            <a:prstDash val="solid"/>
+          </a:ln>
+          <a:effectLst>
+            <a:outerShdw sx="100000" sy="100000" kx="0" ky="0" algn="bl" rotWithShape="0" blurRad="63500" dist="19050" dir="5400000">
+              <a:srgbClr val="000000">
+                <a:alpha val="6000"/>
+              </a:srgbClr>
+            </a:outerShdw>
+          </a:effectLst>
+        </p:spPr>
+      </p:sp>
+      <p:sp>
+        <p:nvSpPr>
+          <p:cNvPr id="17" name="Shape 14"/>
+          <p:cNvSpPr/>
+          <p:nvPr/>
+        </p:nvSpPr>
+        <p:spPr>
+          <a:xfrm>
+            <a:off x="5303520" y="3383280"/>
+            <a:ext cx="64008" cy="822960"/>
+          </a:xfrm>
+          <a:prstGeom prst="rect">
+            <a:avLst/>
+          </a:prstGeom>
+          <a:solidFill>
+            <a:srgbClr val="B91C1C"/>
+          </a:solidFill>
+          <a:ln w="12700">
+            <a:solidFill>
+              <a:srgbClr val="B91C1C"/>
+            </a:solidFill>
+            <a:prstDash val="solid"/>
+          </a:ln>
+        </p:spPr>
+      </p:sp>
+      <p:sp>
+        <p:nvSpPr>
+          <p:cNvPr id="18" name="Text 15"/>
+          <p:cNvSpPr/>
+          <p:nvPr/>
+        </p:nvSpPr>
+        <p:spPr>
+          <a:xfrm>
+            <a:off x="5486400" y="3474720"/>
+            <a:ext cx="3291840" cy="452628"/>
+          </a:xfrm>
+          <a:prstGeom prst="rect">
+            <a:avLst/>
+          </a:prstGeom>
+          <a:noFill/>
+          <a:ln/>
+        </p:spPr>
+        <p:txBody>
+          <a:bodyPr wrap="square" lIns="0" tIns="0" rIns="0" bIns="0" rtlCol="0" anchor="t"/>
+          <a:lstStyle/>
+          <a:p>
+            <a:pPr algn="l" indent="0" marL="0">
+              <a:buNone/>
+            </a:pPr>
+            <a:r>
+              <a:rPr lang="en-US" sz="2100" b="1" dirty="0">
+                <a:solidFill>
+                  <a:srgbClr val="B91C1C"/>
+                </a:solidFill>
+                <a:latin typeface="Georgia" pitchFamily="34" charset="0"/>
+                <a:ea typeface="Georgia" pitchFamily="34" charset="-122"/>
+                <a:cs typeface="Georgia" pitchFamily="34" charset="-120"/>
+              </a:rPr>
+              <a:t>0.7376  ✗</a:t>
+            </a:r>
+            <a:endParaRPr lang="en-US" sz="2100" dirty="0"/>
+          </a:p>
+        </p:txBody>
+      </p:sp>
+      <p:sp>
+        <p:nvSpPr>
+          <p:cNvPr id="19" name="Text 16"/>
+          <p:cNvSpPr/>
+          <p:nvPr/>
+        </p:nvSpPr>
+        <p:spPr>
+          <a:xfrm>
+            <a:off x="5486400" y="3835908"/>
+            <a:ext cx="3291840" cy="370332"/>
+          </a:xfrm>
+          <a:prstGeom prst="rect">
+            <a:avLst/>
+          </a:prstGeom>
+          <a:noFill/>
+          <a:ln/>
+        </p:spPr>
+        <p:txBody>
+          <a:bodyPr wrap="square" lIns="0" tIns="0" rIns="0" bIns="0" rtlCol="0" anchor="t"/>
+          <a:lstStyle/>
+          <a:p>
+            <a:pPr algn="l" indent="0" marL="0">
+              <a:buNone/>
+            </a:pPr>
+            <a:r>
+              <a:rPr lang="en-US" sz="900" dirty="0">
+                <a:solidFill>
+                  <a:srgbClr val="64748B"/>
+                </a:solidFill>
+                <a:latin typeface="Calibri" pitchFamily="34" charset="0"/>
+                <a:ea typeface="Calibri" pitchFamily="34" charset="-122"/>
+                <a:cs typeface="Calibri" pitchFamily="34" charset="-120"/>
+              </a:rPr>
+              <a:t>more capacity (EfficientNetV2-S) — regressed</a:t>
+            </a:r>
+            <a:endParaRPr lang="en-US" sz="900" dirty="0"/>
+          </a:p>
+        </p:txBody>
+      </p:sp>
+      <p:sp>
+        <p:nvSpPr>
+          <p:cNvPr id="20" name="Text 17"/>
+          <p:cNvSpPr/>
+          <p:nvPr/>
+        </p:nvSpPr>
+        <p:spPr>
+          <a:xfrm>
+            <a:off x="5303520" y="4334256"/>
+            <a:ext cx="3566160" cy="502920"/>
+          </a:xfrm>
+          <a:prstGeom prst="rect">
+            <a:avLst/>
+          </a:prstGeom>
+          <a:noFill/>
+          <a:ln/>
+        </p:spPr>
+        <p:txBody>
+          <a:bodyPr wrap="square" lIns="0" tIns="0" rIns="0" bIns="0" rtlCol="0" anchor="ctr"/>
+          <a:lstStyle/>
+          <a:p>
+            <a:pPr indent="0" marL="0">
+              <a:buNone/>
+            </a:pPr>
+            <a:r>
+              <a:rPr lang="en-US" sz="950" i="1" dirty="0">
+                <a:solidFill>
+                  <a:srgbClr val="334155"/>
+                </a:solidFill>
+                <a:latin typeface="Calibri" pitchFamily="34" charset="0"/>
+                <a:ea typeface="Calibri" pitchFamily="34" charset="-122"/>
+                <a:cs typeface="Calibri" pitchFamily="34" charset="-120"/>
+              </a:rPr>
+              <a:t>Of every architecture tried, only fusion design moved the needle — the model is data-bound. Capacity and resolution both hurt.</a:t>
+            </a:r>
+            <a:endParaRPr lang="en-US" sz="950" dirty="0"/>
+          </a:p>
+        </p:txBody>
+      </p:sp>
+      <p:sp>
+        <p:nvSpPr>
+          <p:cNvPr id="21" name="Text 18"/>
+          <p:cNvSpPr/>
+          <p:nvPr/>
+        </p:nvSpPr>
+        <p:spPr>
+          <a:xfrm>
+            <a:off x="274320" y="4846320"/>
+            <a:ext cx="5943600" cy="201168"/>
+          </a:xfrm>
+          <a:prstGeom prst="rect">
+            <a:avLst/>
+          </a:prstGeom>
+          <a:noFill/>
+          <a:ln/>
+        </p:spPr>
+        <p:txBody>
+          <a:bodyPr wrap="square" lIns="0" tIns="0" rIns="0" bIns="0" rtlCol="0" anchor="ctr"/>
+          <a:lstStyle/>
+          <a:p>
+            <a:pPr indent="0" marL="0">
+              <a:buNone/>
+            </a:pPr>
+            <a:r>
+              <a:rPr lang="en-US" sz="900" i="1" dirty="0">
+                <a:solidFill>
+                  <a:srgbClr val="64748B"/>
+                </a:solidFill>
+                <a:latin typeface="Calibri" pitchFamily="34" charset="0"/>
+                <a:ea typeface="Calibri" pitchFamily="34" charset="-122"/>
+                <a:cs typeface="Calibri" pitchFamily="34" charset="-120"/>
+              </a:rPr>
+              <a:t>A3  ·  Multimodal Cancer Cell Classification</a:t>
+            </a:r>
+            <a:endParaRPr lang="en-US" sz="900" dirty="0"/>
+          </a:p>
+        </p:txBody>
+      </p:sp>
+      <p:sp>
+        <p:nvSpPr>
+          <p:cNvPr id="22" name="Text 19"/>
+          <p:cNvSpPr/>
+          <p:nvPr/>
+        </p:nvSpPr>
+        <p:spPr>
+          <a:xfrm>
+            <a:off x="6400800" y="4846320"/>
+            <a:ext cx="2468880" cy="201168"/>
+          </a:xfrm>
+          <a:prstGeom prst="rect">
+            <a:avLst/>
+          </a:prstGeom>
+          <a:noFill/>
+          <a:ln/>
+        </p:spPr>
+        <p:txBody>
+          <a:bodyPr wrap="square" lIns="0" tIns="0" rIns="0" bIns="0" rtlCol="0" anchor="ctr"/>
+          <a:lstStyle/>
+          <a:p>
+            <a:pPr algn="r" indent="0" marL="0">
+              <a:buNone/>
+            </a:pPr>
+            <a:r>
+              <a:rPr lang="en-US" sz="900" i="1" dirty="0">
+                <a:solidFill>
+                  <a:srgbClr val="64748B"/>
+                </a:solidFill>
+                <a:latin typeface="Calibri" pitchFamily="34" charset="0"/>
+                <a:ea typeface="Calibri" pitchFamily="34" charset="-122"/>
+                <a:cs typeface="Calibri" pitchFamily="34" charset="-120"/>
+              </a:rPr>
+              <a:t>Uppsala 1MD042  ·  §11</a:t>
+            </a:r>
+            <a:endParaRPr lang="en-US" sz="900" dirty="0"/>
+          </a:p>
+        </p:txBody>
+      </p:sp>
+    </p:spTree>
+  </p:cSld>
+  <p:clrMapOvr>
+    <a:masterClrMapping/>
+  </p:clrMapOvr>
+</p:sld>
+</file>
+
+<file path=ppt/slides/slide14.xml><?xml version="1.0" encoding="utf-8"?>
+<p:sld xmlns:a="http://schemas.openxmlformats.org/drawingml/2006/main" xmlns:r="http://schemas.openxmlformats.org/officeDocument/2006/relationships" xmlns:p="http://schemas.openxmlformats.org/presentationml/2006/main">
+  <p:cSld name="Slide 14">
     <p:bg>
       <p:bgPr>
         <a:solidFill>
@@ -5999,7 +6851,7 @@
                 <a:ea typeface="Calibri" pitchFamily="34" charset="-122"/>
                 <a:cs typeface="Calibri" pitchFamily="34" charset="-120"/>
               </a:rPr>
-              <a:t>13 / 13</a:t>
+              <a:t>14 / 14</a:t>
             </a:r>
             <a:endParaRPr lang="en-US" sz="1000" dirty="0"/>
           </a:p>
@@ -6038,7 +6890,7 @@
                 <a:ea typeface="Calibri" pitchFamily="34" charset="-122"/>
                 <a:cs typeface="Calibri" pitchFamily="34" charset="-120"/>
               </a:rPr>
-              <a:t>§11  ·  TAKE-HOME</a:t>
+              <a:t>§12  ·  TAKE-HOME</a:t>
             </a:r>
             <a:endParaRPr lang="en-US" sz="1050" dirty="0"/>
           </a:p>
@@ -6545,7 +7397,7 @@
                 <a:ea typeface="Calibri" pitchFamily="34" charset="-122"/>
                 <a:cs typeface="Calibri" pitchFamily="34" charset="-120"/>
               </a:rPr>
-              <a:t>Four regularisers gained +0.011; soft-pseudo distillation gained +0.042. Even the SOTA co-attention fusion ≈ plain late fusion (0.97 corr, both 0.83). Architecture never moved it; only the test-set data did.</a:t>
+              <a:t>Four regularisers gained +0.011; soft-pseudo distillation gained +0.042. Even the SOTA co-attention fusion ≈ plain late fusion (0.97 corr, both 0.83). Only co-attention fusion nudged architecture (+0.004 to a new best 0.8392); data was ~10x bigger.</a:t>
             </a:r>
             <a:endParaRPr lang="en-US" sz="1050" dirty="0"/>
           </a:p>
@@ -6850,7 +7702,7 @@
                 <a:ea typeface="Calibri" pitchFamily="34" charset="-122"/>
                 <a:cs typeface="Calibri" pitchFamily="34" charset="-120"/>
               </a:rPr>
-              <a:t>02 / 13</a:t>
+              <a:t>02 / 14</a:t>
             </a:r>
             <a:endParaRPr lang="en-US" sz="1000" dirty="0"/>
           </a:p>
@@ -8045,7 +8897,7 @@
                 <a:ea typeface="Calibri" pitchFamily="34" charset="-122"/>
                 <a:cs typeface="Calibri" pitchFamily="34" charset="-120"/>
               </a:rPr>
-              <a:t>03 / 13</a:t>
+              <a:t>03 / 14</a:t>
             </a:r>
             <a:endParaRPr lang="en-US" sz="1000" dirty="0"/>
           </a:p>
@@ -8720,7 +9572,7 @@
                 <a:ea typeface="Calibri" pitchFamily="34" charset="-122"/>
                 <a:cs typeface="Calibri" pitchFamily="34" charset="-120"/>
               </a:rPr>
-              <a:t>04 / 13</a:t>
+              <a:t>04 / 14</a:t>
             </a:r>
             <a:endParaRPr lang="en-US" sz="1000" dirty="0"/>
           </a:p>
@@ -10268,7 +11120,7 @@
                 <a:ea typeface="Calibri" pitchFamily="34" charset="-122"/>
                 <a:cs typeface="Calibri" pitchFamily="34" charset="-120"/>
               </a:rPr>
-              <a:t>05 / 13</a:t>
+              <a:t>05 / 14</a:t>
             </a:r>
             <a:endParaRPr lang="en-US" sz="1000" dirty="0"/>
           </a:p>
@@ -11347,7 +12199,7 @@
                 <a:ea typeface="Calibri" pitchFamily="34" charset="-122"/>
                 <a:cs typeface="Calibri" pitchFamily="34" charset="-120"/>
               </a:rPr>
-              <a:t>06 / 13</a:t>
+              <a:t>06 / 14</a:t>
             </a:r>
             <a:endParaRPr lang="en-US" sz="1000" dirty="0"/>
           </a:p>
@@ -12446,7 +13298,7 @@
                 <a:ea typeface="Calibri" pitchFamily="34" charset="-122"/>
                 <a:cs typeface="Calibri" pitchFamily="34" charset="-120"/>
               </a:rPr>
-              <a:t>07 / 13</a:t>
+              <a:t>07 / 14</a:t>
             </a:r>
             <a:endParaRPr lang="en-US" sz="1000" dirty="0"/>
           </a:p>
@@ -13681,7 +14533,7 @@
                 <a:ea typeface="Calibri" pitchFamily="34" charset="-122"/>
                 <a:cs typeface="Calibri" pitchFamily="34" charset="-120"/>
               </a:rPr>
-              <a:t>08 / 13</a:t>
+              <a:t>08 / 14</a:t>
             </a:r>
             <a:endParaRPr lang="en-US" sz="1000" dirty="0"/>
           </a:p>
@@ -13998,7 +14850,7 @@
                 <a:ea typeface="Calibri" pitchFamily="34" charset="-122"/>
                 <a:cs typeface="Calibri" pitchFamily="34" charset="-120"/>
               </a:rPr>
-              <a:t>09 / 13</a:t>
+              <a:t>09 / 14</a:t>
             </a:r>
             <a:endParaRPr lang="en-US" sz="1000" dirty="0"/>
           </a:p>

</xml_diff>